<commit_message>
docs: Arreglos PPT + detalles final
</commit_message>
<xml_diff>
--- a/presentacion/Presentacion_TELCO_EV2.pptx
+++ b/presentacion/Presentacion_TELCO_EV2.pptx
@@ -5,19 +5,19 @@
     <p:sldMasterId id="2147483648" r:id="rId1"/>
   </p:sldMasterIdLst>
   <p:sldIdLst>
-    <p:sldId id="256" r:id="rId7"/>
-    <p:sldId id="257" r:id="rId8"/>
-    <p:sldId id="258" r:id="rId9"/>
-    <p:sldId id="259" r:id="rId10"/>
-    <p:sldId id="260" r:id="rId11"/>
-    <p:sldId id="261" r:id="rId12"/>
-    <p:sldId id="262" r:id="rId13"/>
-    <p:sldId id="263" r:id="rId14"/>
-    <p:sldId id="264" r:id="rId15"/>
-    <p:sldId id="265" r:id="rId16"/>
-    <p:sldId id="266" r:id="rId17"/>
+    <p:sldId id="256" r:id="rId2"/>
+    <p:sldId id="257" r:id="rId3"/>
+    <p:sldId id="258" r:id="rId4"/>
+    <p:sldId id="259" r:id="rId5"/>
+    <p:sldId id="260" r:id="rId6"/>
+    <p:sldId id="261" r:id="rId7"/>
+    <p:sldId id="262" r:id="rId8"/>
+    <p:sldId id="263" r:id="rId9"/>
+    <p:sldId id="264" r:id="rId10"/>
+    <p:sldId id="265" r:id="rId11"/>
+    <p:sldId id="266" r:id="rId12"/>
   </p:sldIdLst>
-  <p:sldSz cx="12191996" cy="6858000" type="screen4x3"/>
+  <p:sldSz cx="12192000" cy="6858000"/>
   <p:notesSz cx="6858000" cy="9144000"/>
   <p:defaultTextStyle>
     <a:defPPr>
@@ -114,6 +114,22 @@
       </a:defRPr>
     </a:lvl9pPr>
   </p:defaultTextStyle>
+  <p:extLst>
+    <p:ext uri="{EFAFB233-063F-42B5-8137-9DF3F51BA10A}">
+      <p15:sldGuideLst xmlns:p15="http://schemas.microsoft.com/office/powerpoint/2012/main">
+        <p15:guide id="1" orient="horz" pos="2160">
+          <p15:clr>
+            <a:srgbClr val="A4A3A4"/>
+          </p15:clr>
+        </p15:guide>
+        <p15:guide id="2" pos="2880">
+          <p15:clr>
+            <a:srgbClr val="A4A3A4"/>
+          </p15:clr>
+        </p15:guide>
+      </p15:sldGuideLst>
+    </p:ext>
+  </p:extLst>
 </p:presentation>
 </file>
 
@@ -155,10 +171,9 @@
           <a:lstStyle/>
           <a:p>
             <a:r>
-              <a:rPr lang="en-US" smtClean="0"/>
+              <a:rPr lang="en-US"/>
               <a:t>Click to edit Master title style</a:t>
             </a:r>
-            <a:endParaRPr lang="en-US"/>
           </a:p>
         </p:txBody>
       </p:sp>
@@ -274,10 +289,9 @@
           </a:lstStyle>
           <a:p>
             <a:r>
-              <a:rPr lang="en-US" smtClean="0"/>
+              <a:rPr lang="en-US"/>
               <a:t>Click to edit Master subtitle style</a:t>
             </a:r>
-            <a:endParaRPr lang="en-US"/>
           </a:p>
         </p:txBody>
       </p:sp>
@@ -298,7 +312,7 @@
           <a:p>
             <a:fld id="{5BCAD085-E8A6-8845-BD4E-CB4CCA059FC4}" type="datetimeFigureOut">
               <a:rPr lang="en-US" smtClean="0"/>
-              <a:t>1/27/13</a:t>
+              <a:t>10/26/2026</a:t>
             </a:fld>
             <a:endParaRPr lang="en-US"/>
           </a:p>
@@ -340,7 +354,7 @@
           <a:p>
             <a:fld id="{C1FF6DA9-008F-8B48-92A6-B652298478BF}" type="slidenum">
               <a:rPr lang="en-US" smtClean="0"/>
-              <a:t>‹#›</a:t>
+              <a:t>‹Nº›</a:t>
             </a:fld>
             <a:endParaRPr lang="en-US"/>
           </a:p>
@@ -392,10 +406,9 @@
           <a:lstStyle/>
           <a:p>
             <a:r>
-              <a:rPr lang="en-US" smtClean="0"/>
+              <a:rPr lang="en-US"/>
               <a:t>Click to edit Master title style</a:t>
             </a:r>
-            <a:endParaRPr lang="en-US"/>
           </a:p>
         </p:txBody>
       </p:sp>
@@ -416,38 +429,37 @@
           <a:p>
             <a:pPr lvl="0"/>
             <a:r>
-              <a:rPr lang="en-US" smtClean="0"/>
+              <a:rPr lang="en-US"/>
               <a:t>Click to edit Master text styles</a:t>
             </a:r>
           </a:p>
           <a:p>
             <a:pPr lvl="1"/>
             <a:r>
-              <a:rPr lang="en-US" smtClean="0"/>
+              <a:rPr lang="en-US"/>
               <a:t>Second level</a:t>
             </a:r>
           </a:p>
           <a:p>
             <a:pPr lvl="2"/>
             <a:r>
-              <a:rPr lang="en-US" smtClean="0"/>
+              <a:rPr lang="en-US"/>
               <a:t>Third level</a:t>
             </a:r>
           </a:p>
           <a:p>
             <a:pPr lvl="3"/>
             <a:r>
-              <a:rPr lang="en-US" smtClean="0"/>
+              <a:rPr lang="en-US"/>
               <a:t>Fourth level</a:t>
             </a:r>
           </a:p>
           <a:p>
             <a:pPr lvl="4"/>
             <a:r>
-              <a:rPr lang="en-US" smtClean="0"/>
+              <a:rPr lang="en-US"/>
               <a:t>Fifth level</a:t>
             </a:r>
-            <a:endParaRPr lang="en-US"/>
           </a:p>
         </p:txBody>
       </p:sp>
@@ -468,7 +480,7 @@
           <a:p>
             <a:fld id="{5BCAD085-E8A6-8845-BD4E-CB4CCA059FC4}" type="datetimeFigureOut">
               <a:rPr lang="en-US" smtClean="0"/>
-              <a:t>1/27/13</a:t>
+              <a:t>10/26/2026</a:t>
             </a:fld>
             <a:endParaRPr lang="en-US"/>
           </a:p>
@@ -510,7 +522,7 @@
           <a:p>
             <a:fld id="{C1FF6DA9-008F-8B48-92A6-B652298478BF}" type="slidenum">
               <a:rPr lang="en-US" smtClean="0"/>
-              <a:t>‹#›</a:t>
+              <a:t>‹Nº›</a:t>
             </a:fld>
             <a:endParaRPr lang="en-US"/>
           </a:p>
@@ -567,10 +579,9 @@
           <a:lstStyle/>
           <a:p>
             <a:r>
-              <a:rPr lang="en-US" smtClean="0"/>
+              <a:rPr lang="en-US"/>
               <a:t>Click to edit Master title style</a:t>
             </a:r>
-            <a:endParaRPr lang="en-US"/>
           </a:p>
         </p:txBody>
       </p:sp>
@@ -596,38 +607,37 @@
           <a:p>
             <a:pPr lvl="0"/>
             <a:r>
-              <a:rPr lang="en-US" smtClean="0"/>
+              <a:rPr lang="en-US"/>
               <a:t>Click to edit Master text styles</a:t>
             </a:r>
           </a:p>
           <a:p>
             <a:pPr lvl="1"/>
             <a:r>
-              <a:rPr lang="en-US" smtClean="0"/>
+              <a:rPr lang="en-US"/>
               <a:t>Second level</a:t>
             </a:r>
           </a:p>
           <a:p>
             <a:pPr lvl="2"/>
             <a:r>
-              <a:rPr lang="en-US" smtClean="0"/>
+              <a:rPr lang="en-US"/>
               <a:t>Third level</a:t>
             </a:r>
           </a:p>
           <a:p>
             <a:pPr lvl="3"/>
             <a:r>
-              <a:rPr lang="en-US" smtClean="0"/>
+              <a:rPr lang="en-US"/>
               <a:t>Fourth level</a:t>
             </a:r>
           </a:p>
           <a:p>
             <a:pPr lvl="4"/>
             <a:r>
-              <a:rPr lang="en-US" smtClean="0"/>
+              <a:rPr lang="en-US"/>
               <a:t>Fifth level</a:t>
             </a:r>
-            <a:endParaRPr lang="en-US"/>
           </a:p>
         </p:txBody>
       </p:sp>
@@ -648,7 +658,7 @@
           <a:p>
             <a:fld id="{5BCAD085-E8A6-8845-BD4E-CB4CCA059FC4}" type="datetimeFigureOut">
               <a:rPr lang="en-US" smtClean="0"/>
-              <a:t>1/27/13</a:t>
+              <a:t>10/26/2026</a:t>
             </a:fld>
             <a:endParaRPr lang="en-US"/>
           </a:p>
@@ -690,7 +700,7 @@
           <a:p>
             <a:fld id="{C1FF6DA9-008F-8B48-92A6-B652298478BF}" type="slidenum">
               <a:rPr lang="en-US" smtClean="0"/>
-              <a:t>‹#›</a:t>
+              <a:t>‹Nº›</a:t>
             </a:fld>
             <a:endParaRPr lang="en-US"/>
           </a:p>
@@ -742,10 +752,9 @@
           <a:lstStyle/>
           <a:p>
             <a:r>
-              <a:rPr lang="en-US" smtClean="0"/>
+              <a:rPr lang="en-US"/>
               <a:t>Click to edit Master title style</a:t>
             </a:r>
-            <a:endParaRPr lang="en-US"/>
           </a:p>
         </p:txBody>
       </p:sp>
@@ -766,38 +775,37 @@
           <a:p>
             <a:pPr lvl="0"/>
             <a:r>
-              <a:rPr lang="en-US" smtClean="0"/>
+              <a:rPr lang="en-US"/>
               <a:t>Click to edit Master text styles</a:t>
             </a:r>
           </a:p>
           <a:p>
             <a:pPr lvl="1"/>
             <a:r>
-              <a:rPr lang="en-US" smtClean="0"/>
+              <a:rPr lang="en-US"/>
               <a:t>Second level</a:t>
             </a:r>
           </a:p>
           <a:p>
             <a:pPr lvl="2"/>
             <a:r>
-              <a:rPr lang="en-US" smtClean="0"/>
+              <a:rPr lang="en-US"/>
               <a:t>Third level</a:t>
             </a:r>
           </a:p>
           <a:p>
             <a:pPr lvl="3"/>
             <a:r>
-              <a:rPr lang="en-US" smtClean="0"/>
+              <a:rPr lang="en-US"/>
               <a:t>Fourth level</a:t>
             </a:r>
           </a:p>
           <a:p>
             <a:pPr lvl="4"/>
             <a:r>
-              <a:rPr lang="en-US" smtClean="0"/>
+              <a:rPr lang="en-US"/>
               <a:t>Fifth level</a:t>
             </a:r>
-            <a:endParaRPr lang="en-US"/>
           </a:p>
         </p:txBody>
       </p:sp>
@@ -818,7 +826,7 @@
           <a:p>
             <a:fld id="{5BCAD085-E8A6-8845-BD4E-CB4CCA059FC4}" type="datetimeFigureOut">
               <a:rPr lang="en-US" smtClean="0"/>
-              <a:t>1/27/13</a:t>
+              <a:t>10/26/2026</a:t>
             </a:fld>
             <a:endParaRPr lang="en-US"/>
           </a:p>
@@ -860,7 +868,7 @@
           <a:p>
             <a:fld id="{C1FF6DA9-008F-8B48-92A6-B652298478BF}" type="slidenum">
               <a:rPr lang="en-US" smtClean="0"/>
-              <a:t>‹#›</a:t>
+              <a:t>‹Nº›</a:t>
             </a:fld>
             <a:endParaRPr lang="en-US"/>
           </a:p>
@@ -921,10 +929,9 @@
           </a:lstStyle>
           <a:p>
             <a:r>
-              <a:rPr lang="en-US" smtClean="0"/>
+              <a:rPr lang="en-US"/>
               <a:t>Click to edit Master title style</a:t>
             </a:r>
-            <a:endParaRPr lang="en-US"/>
           </a:p>
         </p:txBody>
       </p:sp>
@@ -1041,7 +1048,7 @@
           <a:p>
             <a:pPr lvl="0"/>
             <a:r>
-              <a:rPr lang="en-US" smtClean="0"/>
+              <a:rPr lang="en-US"/>
               <a:t>Click to edit Master text styles</a:t>
             </a:r>
           </a:p>
@@ -1064,7 +1071,7 @@
           <a:p>
             <a:fld id="{5BCAD085-E8A6-8845-BD4E-CB4CCA059FC4}" type="datetimeFigureOut">
               <a:rPr lang="en-US" smtClean="0"/>
-              <a:t>1/27/13</a:t>
+              <a:t>10/26/2026</a:t>
             </a:fld>
             <a:endParaRPr lang="en-US"/>
           </a:p>
@@ -1106,7 +1113,7 @@
           <a:p>
             <a:fld id="{C1FF6DA9-008F-8B48-92A6-B652298478BF}" type="slidenum">
               <a:rPr lang="en-US" smtClean="0"/>
-              <a:t>‹#›</a:t>
+              <a:t>‹Nº›</a:t>
             </a:fld>
             <a:endParaRPr lang="en-US"/>
           </a:p>
@@ -1158,10 +1165,9 @@
           <a:lstStyle/>
           <a:p>
             <a:r>
-              <a:rPr lang="en-US" smtClean="0"/>
+              <a:rPr lang="en-US"/>
               <a:t>Click to edit Master title style</a:t>
             </a:r>
-            <a:endParaRPr lang="en-US"/>
           </a:p>
         </p:txBody>
       </p:sp>
@@ -1215,38 +1221,37 @@
           <a:p>
             <a:pPr lvl="0"/>
             <a:r>
-              <a:rPr lang="en-US" smtClean="0"/>
+              <a:rPr lang="en-US"/>
               <a:t>Click to edit Master text styles</a:t>
             </a:r>
           </a:p>
           <a:p>
             <a:pPr lvl="1"/>
             <a:r>
-              <a:rPr lang="en-US" smtClean="0"/>
+              <a:rPr lang="en-US"/>
               <a:t>Second level</a:t>
             </a:r>
           </a:p>
           <a:p>
             <a:pPr lvl="2"/>
             <a:r>
-              <a:rPr lang="en-US" smtClean="0"/>
+              <a:rPr lang="en-US"/>
               <a:t>Third level</a:t>
             </a:r>
           </a:p>
           <a:p>
             <a:pPr lvl="3"/>
             <a:r>
-              <a:rPr lang="en-US" smtClean="0"/>
+              <a:rPr lang="en-US"/>
               <a:t>Fourth level</a:t>
             </a:r>
           </a:p>
           <a:p>
             <a:pPr lvl="4"/>
             <a:r>
-              <a:rPr lang="en-US" smtClean="0"/>
+              <a:rPr lang="en-US"/>
               <a:t>Fifth level</a:t>
             </a:r>
-            <a:endParaRPr lang="en-US"/>
           </a:p>
         </p:txBody>
       </p:sp>
@@ -1300,38 +1305,37 @@
           <a:p>
             <a:pPr lvl="0"/>
             <a:r>
-              <a:rPr lang="en-US" smtClean="0"/>
+              <a:rPr lang="en-US"/>
               <a:t>Click to edit Master text styles</a:t>
             </a:r>
           </a:p>
           <a:p>
             <a:pPr lvl="1"/>
             <a:r>
-              <a:rPr lang="en-US" smtClean="0"/>
+              <a:rPr lang="en-US"/>
               <a:t>Second level</a:t>
             </a:r>
           </a:p>
           <a:p>
             <a:pPr lvl="2"/>
             <a:r>
-              <a:rPr lang="en-US" smtClean="0"/>
+              <a:rPr lang="en-US"/>
               <a:t>Third level</a:t>
             </a:r>
           </a:p>
           <a:p>
             <a:pPr lvl="3"/>
             <a:r>
-              <a:rPr lang="en-US" smtClean="0"/>
+              <a:rPr lang="en-US"/>
               <a:t>Fourth level</a:t>
             </a:r>
           </a:p>
           <a:p>
             <a:pPr lvl="4"/>
             <a:r>
-              <a:rPr lang="en-US" smtClean="0"/>
+              <a:rPr lang="en-US"/>
               <a:t>Fifth level</a:t>
             </a:r>
-            <a:endParaRPr lang="en-US"/>
           </a:p>
         </p:txBody>
       </p:sp>
@@ -1352,7 +1356,7 @@
           <a:p>
             <a:fld id="{5BCAD085-E8A6-8845-BD4E-CB4CCA059FC4}" type="datetimeFigureOut">
               <a:rPr lang="en-US" smtClean="0"/>
-              <a:t>1/27/13</a:t>
+              <a:t>10/26/2026</a:t>
             </a:fld>
             <a:endParaRPr lang="en-US"/>
           </a:p>
@@ -1394,7 +1398,7 @@
           <a:p>
             <a:fld id="{C1FF6DA9-008F-8B48-92A6-B652298478BF}" type="slidenum">
               <a:rPr lang="en-US" smtClean="0"/>
-              <a:t>‹#›</a:t>
+              <a:t>‹Nº›</a:t>
             </a:fld>
             <a:endParaRPr lang="en-US"/>
           </a:p>
@@ -1450,10 +1454,9 @@
           </a:lstStyle>
           <a:p>
             <a:r>
-              <a:rPr lang="en-US" smtClean="0"/>
+              <a:rPr lang="en-US"/>
               <a:t>Click to edit Master title style</a:t>
             </a:r>
-            <a:endParaRPr lang="en-US"/>
           </a:p>
         </p:txBody>
       </p:sp>
@@ -1516,7 +1519,7 @@
           <a:p>
             <a:pPr lvl="0"/>
             <a:r>
-              <a:rPr lang="en-US" smtClean="0"/>
+              <a:rPr lang="en-US"/>
               <a:t>Click to edit Master text styles</a:t>
             </a:r>
           </a:p>
@@ -1572,38 +1575,37 @@
           <a:p>
             <a:pPr lvl="0"/>
             <a:r>
-              <a:rPr lang="en-US" smtClean="0"/>
+              <a:rPr lang="en-US"/>
               <a:t>Click to edit Master text styles</a:t>
             </a:r>
           </a:p>
           <a:p>
             <a:pPr lvl="1"/>
             <a:r>
-              <a:rPr lang="en-US" smtClean="0"/>
+              <a:rPr lang="en-US"/>
               <a:t>Second level</a:t>
             </a:r>
           </a:p>
           <a:p>
             <a:pPr lvl="2"/>
             <a:r>
-              <a:rPr lang="en-US" smtClean="0"/>
+              <a:rPr lang="en-US"/>
               <a:t>Third level</a:t>
             </a:r>
           </a:p>
           <a:p>
             <a:pPr lvl="3"/>
             <a:r>
-              <a:rPr lang="en-US" smtClean="0"/>
+              <a:rPr lang="en-US"/>
               <a:t>Fourth level</a:t>
             </a:r>
           </a:p>
           <a:p>
             <a:pPr lvl="4"/>
             <a:r>
-              <a:rPr lang="en-US" smtClean="0"/>
+              <a:rPr lang="en-US"/>
               <a:t>Fifth level</a:t>
             </a:r>
-            <a:endParaRPr lang="en-US"/>
           </a:p>
         </p:txBody>
       </p:sp>
@@ -1666,7 +1668,7 @@
           <a:p>
             <a:pPr lvl="0"/>
             <a:r>
-              <a:rPr lang="en-US" smtClean="0"/>
+              <a:rPr lang="en-US"/>
               <a:t>Click to edit Master text styles</a:t>
             </a:r>
           </a:p>
@@ -1722,38 +1724,37 @@
           <a:p>
             <a:pPr lvl="0"/>
             <a:r>
-              <a:rPr lang="en-US" smtClean="0"/>
+              <a:rPr lang="en-US"/>
               <a:t>Click to edit Master text styles</a:t>
             </a:r>
           </a:p>
           <a:p>
             <a:pPr lvl="1"/>
             <a:r>
-              <a:rPr lang="en-US" smtClean="0"/>
+              <a:rPr lang="en-US"/>
               <a:t>Second level</a:t>
             </a:r>
           </a:p>
           <a:p>
             <a:pPr lvl="2"/>
             <a:r>
-              <a:rPr lang="en-US" smtClean="0"/>
+              <a:rPr lang="en-US"/>
               <a:t>Third level</a:t>
             </a:r>
           </a:p>
           <a:p>
             <a:pPr lvl="3"/>
             <a:r>
-              <a:rPr lang="en-US" smtClean="0"/>
+              <a:rPr lang="en-US"/>
               <a:t>Fourth level</a:t>
             </a:r>
           </a:p>
           <a:p>
             <a:pPr lvl="4"/>
             <a:r>
-              <a:rPr lang="en-US" smtClean="0"/>
+              <a:rPr lang="en-US"/>
               <a:t>Fifth level</a:t>
             </a:r>
-            <a:endParaRPr lang="en-US"/>
           </a:p>
         </p:txBody>
       </p:sp>
@@ -1774,7 +1775,7 @@
           <a:p>
             <a:fld id="{5BCAD085-E8A6-8845-BD4E-CB4CCA059FC4}" type="datetimeFigureOut">
               <a:rPr lang="en-US" smtClean="0"/>
-              <a:t>1/27/13</a:t>
+              <a:t>10/26/2026</a:t>
             </a:fld>
             <a:endParaRPr lang="en-US"/>
           </a:p>
@@ -1816,7 +1817,7 @@
           <a:p>
             <a:fld id="{C1FF6DA9-008F-8B48-92A6-B652298478BF}" type="slidenum">
               <a:rPr lang="en-US" smtClean="0"/>
-              <a:t>‹#›</a:t>
+              <a:t>‹Nº›</a:t>
             </a:fld>
             <a:endParaRPr lang="en-US"/>
           </a:p>
@@ -1868,10 +1869,9 @@
           <a:lstStyle/>
           <a:p>
             <a:r>
-              <a:rPr lang="en-US" smtClean="0"/>
+              <a:rPr lang="en-US"/>
               <a:t>Click to edit Master title style</a:t>
             </a:r>
-            <a:endParaRPr lang="en-US"/>
           </a:p>
         </p:txBody>
       </p:sp>
@@ -1892,7 +1892,7 @@
           <a:p>
             <a:fld id="{5BCAD085-E8A6-8845-BD4E-CB4CCA059FC4}" type="datetimeFigureOut">
               <a:rPr lang="en-US" smtClean="0"/>
-              <a:t>1/27/13</a:t>
+              <a:t>10/26/2026</a:t>
             </a:fld>
             <a:endParaRPr lang="en-US"/>
           </a:p>
@@ -1934,7 +1934,7 @@
           <a:p>
             <a:fld id="{C1FF6DA9-008F-8B48-92A6-B652298478BF}" type="slidenum">
               <a:rPr lang="en-US" smtClean="0"/>
-              <a:t>‹#›</a:t>
+              <a:t>‹Nº›</a:t>
             </a:fld>
             <a:endParaRPr lang="en-US"/>
           </a:p>
@@ -1987,7 +1987,7 @@
           <a:p>
             <a:fld id="{5BCAD085-E8A6-8845-BD4E-CB4CCA059FC4}" type="datetimeFigureOut">
               <a:rPr lang="en-US" smtClean="0"/>
-              <a:t>1/27/13</a:t>
+              <a:t>10/26/2026</a:t>
             </a:fld>
             <a:endParaRPr lang="en-US"/>
           </a:p>
@@ -2029,7 +2029,7 @@
           <a:p>
             <a:fld id="{C1FF6DA9-008F-8B48-92A6-B652298478BF}" type="slidenum">
               <a:rPr lang="en-US" smtClean="0"/>
-              <a:t>‹#›</a:t>
+              <a:t>‹Nº›</a:t>
             </a:fld>
             <a:endParaRPr lang="en-US"/>
           </a:p>
@@ -2090,10 +2090,9 @@
           </a:lstStyle>
           <a:p>
             <a:r>
-              <a:rPr lang="en-US" smtClean="0"/>
+              <a:rPr lang="en-US"/>
               <a:t>Click to edit Master title style</a:t>
             </a:r>
-            <a:endParaRPr lang="en-US"/>
           </a:p>
         </p:txBody>
       </p:sp>
@@ -2147,38 +2146,37 @@
           <a:p>
             <a:pPr lvl="0"/>
             <a:r>
-              <a:rPr lang="en-US" smtClean="0"/>
+              <a:rPr lang="en-US"/>
               <a:t>Click to edit Master text styles</a:t>
             </a:r>
           </a:p>
           <a:p>
             <a:pPr lvl="1"/>
             <a:r>
-              <a:rPr lang="en-US" smtClean="0"/>
+              <a:rPr lang="en-US"/>
               <a:t>Second level</a:t>
             </a:r>
           </a:p>
           <a:p>
             <a:pPr lvl="2"/>
             <a:r>
-              <a:rPr lang="en-US" smtClean="0"/>
+              <a:rPr lang="en-US"/>
               <a:t>Third level</a:t>
             </a:r>
           </a:p>
           <a:p>
             <a:pPr lvl="3"/>
             <a:r>
-              <a:rPr lang="en-US" smtClean="0"/>
+              <a:rPr lang="en-US"/>
               <a:t>Fourth level</a:t>
             </a:r>
           </a:p>
           <a:p>
             <a:pPr lvl="4"/>
             <a:r>
-              <a:rPr lang="en-US" smtClean="0"/>
+              <a:rPr lang="en-US"/>
               <a:t>Fifth level</a:t>
             </a:r>
-            <a:endParaRPr lang="en-US"/>
           </a:p>
         </p:txBody>
       </p:sp>
@@ -2241,7 +2239,7 @@
           <a:p>
             <a:pPr lvl="0"/>
             <a:r>
-              <a:rPr lang="en-US" smtClean="0"/>
+              <a:rPr lang="en-US"/>
               <a:t>Click to edit Master text styles</a:t>
             </a:r>
           </a:p>
@@ -2264,7 +2262,7 @@
           <a:p>
             <a:fld id="{5BCAD085-E8A6-8845-BD4E-CB4CCA059FC4}" type="datetimeFigureOut">
               <a:rPr lang="en-US" smtClean="0"/>
-              <a:t>1/27/13</a:t>
+              <a:t>10/26/2026</a:t>
             </a:fld>
             <a:endParaRPr lang="en-US"/>
           </a:p>
@@ -2306,7 +2304,7 @@
           <a:p>
             <a:fld id="{C1FF6DA9-008F-8B48-92A6-B652298478BF}" type="slidenum">
               <a:rPr lang="en-US" smtClean="0"/>
-              <a:t>‹#›</a:t>
+              <a:t>‹Nº›</a:t>
             </a:fld>
             <a:endParaRPr lang="en-US"/>
           </a:p>
@@ -2367,10 +2365,9 @@
           </a:lstStyle>
           <a:p>
             <a:r>
-              <a:rPr lang="en-US" smtClean="0"/>
+              <a:rPr lang="en-US"/>
               <a:t>Click to edit Master title style</a:t>
             </a:r>
-            <a:endParaRPr lang="en-US"/>
           </a:p>
         </p:txBody>
       </p:sp>
@@ -2494,7 +2491,7 @@
           <a:p>
             <a:pPr lvl="0"/>
             <a:r>
-              <a:rPr lang="en-US" smtClean="0"/>
+              <a:rPr lang="en-US"/>
               <a:t>Click to edit Master text styles</a:t>
             </a:r>
           </a:p>
@@ -2517,7 +2514,7 @@
           <a:p>
             <a:fld id="{5BCAD085-E8A6-8845-BD4E-CB4CCA059FC4}" type="datetimeFigureOut">
               <a:rPr lang="en-US" smtClean="0"/>
-              <a:t>1/27/13</a:t>
+              <a:t>10/26/2026</a:t>
             </a:fld>
             <a:endParaRPr lang="en-US"/>
           </a:p>
@@ -2559,7 +2556,7 @@
           <a:p>
             <a:fld id="{C1FF6DA9-008F-8B48-92A6-B652298478BF}" type="slidenum">
               <a:rPr lang="en-US" smtClean="0"/>
-              <a:t>‹#›</a:t>
+              <a:t>‹Nº›</a:t>
             </a:fld>
             <a:endParaRPr lang="en-US"/>
           </a:p>
@@ -2626,10 +2623,9 @@
           <a:lstStyle/>
           <a:p>
             <a:r>
-              <a:rPr lang="en-US" smtClean="0"/>
+              <a:rPr lang="en-US"/>
               <a:t>Click to edit Master title style</a:t>
             </a:r>
-            <a:endParaRPr lang="en-US"/>
           </a:p>
         </p:txBody>
       </p:sp>
@@ -2660,38 +2656,37 @@
           <a:p>
             <a:pPr lvl="0"/>
             <a:r>
-              <a:rPr lang="en-US" smtClean="0"/>
+              <a:rPr lang="en-US"/>
               <a:t>Click to edit Master text styles</a:t>
             </a:r>
           </a:p>
           <a:p>
             <a:pPr lvl="1"/>
             <a:r>
-              <a:rPr lang="en-US" smtClean="0"/>
+              <a:rPr lang="en-US"/>
               <a:t>Second level</a:t>
             </a:r>
           </a:p>
           <a:p>
             <a:pPr lvl="2"/>
             <a:r>
-              <a:rPr lang="en-US" smtClean="0"/>
+              <a:rPr lang="en-US"/>
               <a:t>Third level</a:t>
             </a:r>
           </a:p>
           <a:p>
             <a:pPr lvl="3"/>
             <a:r>
-              <a:rPr lang="en-US" smtClean="0"/>
+              <a:rPr lang="en-US"/>
               <a:t>Fourth level</a:t>
             </a:r>
           </a:p>
           <a:p>
             <a:pPr lvl="4"/>
             <a:r>
-              <a:rPr lang="en-US" smtClean="0"/>
+              <a:rPr lang="en-US"/>
               <a:t>Fifth level</a:t>
             </a:r>
-            <a:endParaRPr lang="en-US"/>
           </a:p>
         </p:txBody>
       </p:sp>
@@ -2730,7 +2725,7 @@
           <a:p>
             <a:fld id="{5BCAD085-E8A6-8845-BD4E-CB4CCA059FC4}" type="datetimeFigureOut">
               <a:rPr lang="en-US" smtClean="0"/>
-              <a:t>1/27/13</a:t>
+              <a:t>10/26/2026</a:t>
             </a:fld>
             <a:endParaRPr lang="en-US"/>
           </a:p>
@@ -2808,7 +2803,7 @@
           <a:p>
             <a:fld id="{C1FF6DA9-008F-8B48-92A6-B652298478BF}" type="slidenum">
               <a:rPr lang="en-US" smtClean="0"/>
-              <a:t>‹#›</a:t>
+              <a:t>‹Nº›</a:t>
             </a:fld>
             <a:endParaRPr lang="en-US"/>
           </a:p>
@@ -3089,7 +3084,7 @@
 </file>
 
 <file path=ppt/slides/slide1.xml><?xml version="1.0" encoding="utf-8"?>
-<p:sld xmlns:a="http://schemas.openxmlformats.org/drawingml/2006/main" xmlns:p="http://schemas.openxmlformats.org/presentationml/2006/main" xmlns:r="http://schemas.openxmlformats.org/officeDocument/2006/relationships">
+<p:sld xmlns:a="http://schemas.openxmlformats.org/drawingml/2006/main" xmlns:r="http://schemas.openxmlformats.org/officeDocument/2006/relationships" xmlns:p="http://schemas.openxmlformats.org/presentationml/2006/main">
   <p:cSld>
     <p:bg>
       <p:bgPr>
@@ -3105,7 +3100,14 @@
         <p:cNvGrpSpPr/>
         <p:nvPr/>
       </p:nvGrpSpPr>
-      <p:grpSpPr/>
+      <p:grpSpPr>
+        <a:xfrm>
+          <a:off x="0" y="0"/>
+          <a:ext cx="0" cy="0"/>
+          <a:chOff x="0" y="0"/>
+          <a:chExt cx="0" cy="0"/>
+        </a:xfrm>
+      </p:grpSpPr>
       <p:sp>
         <p:nvSpPr>
           <p:cNvPr id="2" name="Rectangle 1"/>
@@ -3146,6 +3148,7 @@
           <a:lstStyle/>
           <a:p>
             <a:pPr algn="ctr"/>
+            <a:endParaRPr/>
           </a:p>
         </p:txBody>
       </p:sp>
@@ -3259,6 +3262,7 @@
           <a:lstStyle/>
           <a:p>
             <a:pPr algn="ctr"/>
+            <a:endParaRPr/>
           </a:p>
         </p:txBody>
       </p:sp>
@@ -3302,6 +3306,7 @@
           <a:lstStyle/>
           <a:p>
             <a:pPr algn="ctr"/>
+            <a:endParaRPr/>
           </a:p>
         </p:txBody>
       </p:sp>
@@ -3345,6 +3350,7 @@
           <a:lstStyle/>
           <a:p>
             <a:pPr algn="ctr"/>
+            <a:endParaRPr/>
           </a:p>
         </p:txBody>
       </p:sp>
@@ -3365,7 +3371,7 @@
           <a:noFill/>
         </p:spPr>
         <p:txBody>
-          <a:bodyPr wrap="square" lIns="0" rIns="0" tIns="0" bIns="0" anchor="t">
+          <a:bodyPr wrap="square" lIns="0" tIns="0" rIns="0" bIns="0" anchor="t">
             <a:spAutoFit/>
           </a:bodyPr>
           <a:lstStyle/>
@@ -3410,7 +3416,7 @@
           <a:noFill/>
         </p:spPr>
         <p:txBody>
-          <a:bodyPr wrap="square" lIns="0" rIns="0" tIns="0" bIns="0" anchor="t">
+          <a:bodyPr wrap="square" lIns="0" tIns="0" rIns="0" bIns="0" anchor="t">
             <a:spAutoFit/>
           </a:bodyPr>
           <a:lstStyle/>
@@ -3455,7 +3461,7 @@
           <a:noFill/>
         </p:spPr>
         <p:txBody>
-          <a:bodyPr wrap="square" lIns="0" rIns="0" tIns="0" bIns="0" anchor="t">
+          <a:bodyPr wrap="square" lIns="0" tIns="0" rIns="0" bIns="0" anchor="t">
             <a:spAutoFit/>
           </a:bodyPr>
           <a:lstStyle/>
@@ -3522,7 +3528,7 @@
           <a:noFill/>
         </p:spPr>
         <p:txBody>
-          <a:bodyPr wrap="square" lIns="0" rIns="0" tIns="0" bIns="0" anchor="t">
+          <a:bodyPr wrap="square" lIns="0" tIns="0" rIns="0" bIns="0" anchor="t">
             <a:spAutoFit/>
           </a:bodyPr>
           <a:lstStyle/>
@@ -3602,7 +3608,7 @@
           <a:noFill/>
         </p:spPr>
         <p:txBody>
-          <a:bodyPr wrap="square" lIns="0" rIns="0" tIns="0" bIns="0" anchor="t">
+          <a:bodyPr wrap="square" lIns="0" tIns="0" rIns="0" bIns="0" anchor="t">
             <a:spAutoFit/>
           </a:bodyPr>
           <a:lstStyle/>
@@ -3647,7 +3653,7 @@
           <a:noFill/>
         </p:spPr>
         <p:txBody>
-          <a:bodyPr wrap="square" lIns="0" rIns="0" tIns="0" bIns="0" anchor="t">
+          <a:bodyPr wrap="square" lIns="0" tIns="0" rIns="0" bIns="0" anchor="t">
             <a:spAutoFit/>
           </a:bodyPr>
           <a:lstStyle/>
@@ -3715,6 +3721,7 @@
           <a:lstStyle/>
           <a:p>
             <a:pPr algn="ctr"/>
+            <a:endParaRPr/>
           </a:p>
         </p:txBody>
       </p:sp>
@@ -3758,6 +3765,7 @@
           <a:lstStyle/>
           <a:p>
             <a:pPr algn="ctr"/>
+            <a:endParaRPr/>
           </a:p>
         </p:txBody>
       </p:sp>
@@ -3941,6 +3949,7 @@
           <a:lstStyle/>
           <a:p>
             <a:pPr algn="ctr"/>
+            <a:endParaRPr/>
           </a:p>
         </p:txBody>
       </p:sp>
@@ -3984,6 +3993,7 @@
           <a:lstStyle/>
           <a:p>
             <a:pPr algn="ctr"/>
+            <a:endParaRPr/>
           </a:p>
         </p:txBody>
       </p:sp>
@@ -4027,6 +4037,7 @@
           <a:lstStyle/>
           <a:p>
             <a:pPr algn="ctr"/>
+            <a:endParaRPr/>
           </a:p>
         </p:txBody>
       </p:sp>
@@ -4070,6 +4081,7 @@
           <a:lstStyle/>
           <a:p>
             <a:pPr algn="ctr"/>
+            <a:endParaRPr/>
           </a:p>
         </p:txBody>
       </p:sp>
@@ -4090,7 +4102,7 @@
           <a:noFill/>
         </p:spPr>
         <p:txBody>
-          <a:bodyPr wrap="square" lIns="0" rIns="0" tIns="0" bIns="0" anchor="t">
+          <a:bodyPr wrap="square" lIns="0" tIns="0" rIns="0" bIns="0" anchor="t">
             <a:spAutoFit/>
           </a:bodyPr>
           <a:lstStyle/>
@@ -4149,7 +4161,7 @@
 </file>
 
 <file path=ppt/slides/slide10.xml><?xml version="1.0" encoding="utf-8"?>
-<p:sld xmlns:a="http://schemas.openxmlformats.org/drawingml/2006/main" xmlns:p="http://schemas.openxmlformats.org/presentationml/2006/main" xmlns:r="http://schemas.openxmlformats.org/officeDocument/2006/relationships">
+<p:sld xmlns:a="http://schemas.openxmlformats.org/drawingml/2006/main" xmlns:r="http://schemas.openxmlformats.org/officeDocument/2006/relationships" xmlns:p="http://schemas.openxmlformats.org/presentationml/2006/main">
   <p:cSld>
     <p:bg>
       <p:bgPr>
@@ -4165,7 +4177,14 @@
         <p:cNvGrpSpPr/>
         <p:nvPr/>
       </p:nvGrpSpPr>
-      <p:grpSpPr/>
+      <p:grpSpPr>
+        <a:xfrm>
+          <a:off x="0" y="0"/>
+          <a:ext cx="0" cy="0"/>
+          <a:chOff x="0" y="0"/>
+          <a:chExt cx="0" cy="0"/>
+        </a:xfrm>
+      </p:grpSpPr>
       <p:cxnSp>
         <p:nvCxnSpPr>
           <p:cNvPr id="2" name="Connector 1"/>
@@ -4276,6 +4295,7 @@
           <a:lstStyle/>
           <a:p>
             <a:pPr algn="ctr"/>
+            <a:endParaRPr/>
           </a:p>
         </p:txBody>
       </p:sp>
@@ -4319,6 +4339,7 @@
           <a:lstStyle/>
           <a:p>
             <a:pPr algn="ctr"/>
+            <a:endParaRPr/>
           </a:p>
         </p:txBody>
       </p:sp>
@@ -4362,6 +4383,7 @@
           <a:lstStyle/>
           <a:p>
             <a:pPr algn="ctr"/>
+            <a:endParaRPr/>
           </a:p>
         </p:txBody>
       </p:sp>
@@ -4382,7 +4404,7 @@
           <a:noFill/>
         </p:spPr>
         <p:txBody>
-          <a:bodyPr wrap="square" lIns="0" rIns="0" tIns="0" bIns="0" anchor="t">
+          <a:bodyPr wrap="square" lIns="0" tIns="0" rIns="0" bIns="0" anchor="t">
             <a:spAutoFit/>
           </a:bodyPr>
           <a:lstStyle/>
@@ -4427,7 +4449,7 @@
           <a:noFill/>
         </p:spPr>
         <p:txBody>
-          <a:bodyPr wrap="square" lIns="0" rIns="0" tIns="0" bIns="0" anchor="t">
+          <a:bodyPr wrap="square" lIns="0" tIns="0" rIns="0" bIns="0" anchor="t">
             <a:spAutoFit/>
           </a:bodyPr>
           <a:lstStyle/>
@@ -4507,7 +4529,7 @@
           <a:noFill/>
         </p:spPr>
         <p:txBody>
-          <a:bodyPr wrap="square" lIns="0" rIns="0" tIns="0" bIns="0" anchor="t">
+          <a:bodyPr wrap="square" lIns="0" tIns="0" rIns="0" bIns="0" anchor="t">
             <a:spAutoFit/>
           </a:bodyPr>
           <a:lstStyle/>
@@ -4552,7 +4574,7 @@
           <a:noFill/>
         </p:spPr>
         <p:txBody>
-          <a:bodyPr wrap="square" lIns="0" rIns="0" tIns="0" bIns="0" anchor="t">
+          <a:bodyPr wrap="square" lIns="0" tIns="0" rIns="0" bIns="0" anchor="t">
             <a:spAutoFit/>
           </a:bodyPr>
           <a:lstStyle/>
@@ -4597,7 +4619,7 @@
           <a:noFill/>
         </p:spPr>
         <p:txBody>
-          <a:bodyPr wrap="square" lIns="0" rIns="0" tIns="0" bIns="0" anchor="t">
+          <a:bodyPr wrap="square" lIns="0" tIns="0" rIns="0" bIns="0" anchor="t">
             <a:spAutoFit/>
           </a:bodyPr>
           <a:lstStyle/>
@@ -4665,6 +4687,7 @@
           <a:lstStyle/>
           <a:p>
             <a:pPr algn="ctr"/>
+            <a:endParaRPr/>
           </a:p>
         </p:txBody>
       </p:sp>
@@ -4708,6 +4731,7 @@
           <a:lstStyle/>
           <a:p>
             <a:pPr algn="ctr"/>
+            <a:endParaRPr/>
           </a:p>
         </p:txBody>
       </p:sp>
@@ -4751,6 +4775,7 @@
           <a:lstStyle/>
           <a:p>
             <a:pPr algn="ctr"/>
+            <a:endParaRPr/>
           </a:p>
         </p:txBody>
       </p:sp>
@@ -4794,6 +4819,7 @@
           <a:lstStyle/>
           <a:p>
             <a:pPr algn="ctr"/>
+            <a:endParaRPr/>
           </a:p>
         </p:txBody>
       </p:sp>
@@ -4837,6 +4863,7 @@
           <a:lstStyle/>
           <a:p>
             <a:pPr algn="ctr"/>
+            <a:endParaRPr/>
           </a:p>
         </p:txBody>
       </p:sp>
@@ -4880,6 +4907,7 @@
           <a:lstStyle/>
           <a:p>
             <a:pPr algn="ctr"/>
+            <a:endParaRPr/>
           </a:p>
         </p:txBody>
       </p:sp>
@@ -4923,6 +4951,7 @@
           <a:lstStyle/>
           <a:p>
             <a:pPr algn="ctr"/>
+            <a:endParaRPr/>
           </a:p>
         </p:txBody>
       </p:sp>
@@ -4966,6 +4995,7 @@
           <a:lstStyle/>
           <a:p>
             <a:pPr algn="ctr"/>
+            <a:endParaRPr/>
           </a:p>
         </p:txBody>
       </p:sp>
@@ -5009,6 +5039,7 @@
           <a:lstStyle/>
           <a:p>
             <a:pPr algn="ctr"/>
+            <a:endParaRPr/>
           </a:p>
         </p:txBody>
       </p:sp>
@@ -5052,6 +5083,7 @@
           <a:lstStyle/>
           <a:p>
             <a:pPr algn="ctr"/>
+            <a:endParaRPr/>
           </a:p>
         </p:txBody>
       </p:sp>
@@ -5095,6 +5127,7 @@
           <a:lstStyle/>
           <a:p>
             <a:pPr algn="ctr"/>
+            <a:endParaRPr/>
           </a:p>
         </p:txBody>
       </p:sp>
@@ -5115,7 +5148,7 @@
           <a:noFill/>
         </p:spPr>
         <p:txBody>
-          <a:bodyPr wrap="square" lIns="0" rIns="0" tIns="0" bIns="0" anchor="t">
+          <a:bodyPr wrap="square" lIns="0" tIns="0" rIns="0" bIns="0" anchor="t">
             <a:spAutoFit/>
           </a:bodyPr>
           <a:lstStyle/>
@@ -5160,7 +5193,7 @@
           <a:noFill/>
         </p:spPr>
         <p:txBody>
-          <a:bodyPr wrap="square" lIns="0" rIns="0" tIns="0" bIns="0" anchor="t">
+          <a:bodyPr wrap="square" lIns="0" tIns="0" rIns="0" bIns="0" anchor="t">
             <a:spAutoFit/>
           </a:bodyPr>
           <a:lstStyle/>
@@ -5228,6 +5261,7 @@
           <a:lstStyle/>
           <a:p>
             <a:pPr algn="ctr"/>
+            <a:endParaRPr/>
           </a:p>
         </p:txBody>
       </p:sp>
@@ -5248,7 +5282,7 @@
           <a:noFill/>
         </p:spPr>
         <p:txBody>
-          <a:bodyPr wrap="square" lIns="0" rIns="0" tIns="0" bIns="0" anchor="t">
+          <a:bodyPr wrap="square" lIns="0" tIns="0" rIns="0" bIns="0" anchor="t">
             <a:spAutoFit/>
           </a:bodyPr>
           <a:lstStyle/>
@@ -5293,7 +5327,7 @@
           <a:noFill/>
         </p:spPr>
         <p:txBody>
-          <a:bodyPr wrap="square" lIns="0" rIns="0" tIns="0" bIns="0" anchor="t">
+          <a:bodyPr wrap="square" lIns="0" tIns="0" rIns="0" bIns="0" anchor="t">
             <a:spAutoFit/>
           </a:bodyPr>
           <a:lstStyle/>
@@ -5338,7 +5372,7 @@
           <a:noFill/>
         </p:spPr>
         <p:txBody>
-          <a:bodyPr wrap="square" lIns="0" rIns="0" tIns="0" bIns="0" anchor="t">
+          <a:bodyPr wrap="square" lIns="0" tIns="0" rIns="0" bIns="0" anchor="t">
             <a:spAutoFit/>
           </a:bodyPr>
           <a:lstStyle/>
@@ -5441,6 +5475,7 @@
           <a:lstStyle/>
           <a:p>
             <a:pPr algn="ctr"/>
+            <a:endParaRPr/>
           </a:p>
         </p:txBody>
       </p:sp>
@@ -5461,7 +5496,7 @@
           <a:noFill/>
         </p:spPr>
         <p:txBody>
-          <a:bodyPr wrap="square" lIns="0" rIns="0" tIns="0" bIns="0" anchor="t">
+          <a:bodyPr wrap="square" lIns="0" tIns="0" rIns="0" bIns="0" anchor="t">
             <a:spAutoFit/>
           </a:bodyPr>
           <a:lstStyle/>
@@ -5506,7 +5541,7 @@
           <a:noFill/>
         </p:spPr>
         <p:txBody>
-          <a:bodyPr wrap="square" lIns="0" rIns="0" tIns="0" bIns="0" anchor="t">
+          <a:bodyPr wrap="square" lIns="0" tIns="0" rIns="0" bIns="0" anchor="t">
             <a:spAutoFit/>
           </a:bodyPr>
           <a:lstStyle/>
@@ -5551,7 +5586,7 @@
           <a:noFill/>
         </p:spPr>
         <p:txBody>
-          <a:bodyPr wrap="square" lIns="0" rIns="0" tIns="0" bIns="0" anchor="t">
+          <a:bodyPr wrap="square" lIns="0" tIns="0" rIns="0" bIns="0" anchor="t">
             <a:spAutoFit/>
           </a:bodyPr>
           <a:lstStyle/>
@@ -5654,6 +5689,7 @@
           <a:lstStyle/>
           <a:p>
             <a:pPr algn="ctr"/>
+            <a:endParaRPr/>
           </a:p>
         </p:txBody>
       </p:sp>
@@ -5674,7 +5710,7 @@
           <a:noFill/>
         </p:spPr>
         <p:txBody>
-          <a:bodyPr wrap="square" lIns="0" rIns="0" tIns="0" bIns="0" anchor="t">
+          <a:bodyPr wrap="square" lIns="0" tIns="0" rIns="0" bIns="0" anchor="t">
             <a:spAutoFit/>
           </a:bodyPr>
           <a:lstStyle/>
@@ -5719,7 +5755,7 @@
           <a:noFill/>
         </p:spPr>
         <p:txBody>
-          <a:bodyPr wrap="square" lIns="0" rIns="0" tIns="0" bIns="0" anchor="t">
+          <a:bodyPr wrap="square" lIns="0" tIns="0" rIns="0" bIns="0" anchor="t">
             <a:spAutoFit/>
           </a:bodyPr>
           <a:lstStyle/>
@@ -5764,7 +5800,7 @@
           <a:noFill/>
         </p:spPr>
         <p:txBody>
-          <a:bodyPr wrap="square" lIns="0" rIns="0" tIns="0" bIns="0" anchor="t">
+          <a:bodyPr wrap="square" lIns="0" tIns="0" rIns="0" bIns="0" anchor="t">
             <a:spAutoFit/>
           </a:bodyPr>
           <a:lstStyle/>
@@ -5844,7 +5880,7 @@
           <a:noFill/>
         </p:spPr>
         <p:txBody>
-          <a:bodyPr wrap="square" lIns="0" rIns="0" tIns="0" bIns="0" anchor="t">
+          <a:bodyPr wrap="square" lIns="0" tIns="0" rIns="0" bIns="0" anchor="t">
             <a:spAutoFit/>
           </a:bodyPr>
           <a:lstStyle/>
@@ -5881,7 +5917,7 @@
 </file>
 
 <file path=ppt/slides/slide11.xml><?xml version="1.0" encoding="utf-8"?>
-<p:sld xmlns:a="http://schemas.openxmlformats.org/drawingml/2006/main" xmlns:p="http://schemas.openxmlformats.org/presentationml/2006/main" xmlns:r="http://schemas.openxmlformats.org/officeDocument/2006/relationships">
+<p:sld xmlns:a="http://schemas.openxmlformats.org/drawingml/2006/main" xmlns:r="http://schemas.openxmlformats.org/officeDocument/2006/relationships" xmlns:p="http://schemas.openxmlformats.org/presentationml/2006/main">
   <p:cSld>
     <p:bg>
       <p:bgPr>
@@ -5897,7 +5933,14 @@
         <p:cNvGrpSpPr/>
         <p:nvPr/>
       </p:nvGrpSpPr>
-      <p:grpSpPr/>
+      <p:grpSpPr>
+        <a:xfrm>
+          <a:off x="0" y="0"/>
+          <a:ext cx="0" cy="0"/>
+          <a:chOff x="0" y="0"/>
+          <a:chExt cx="0" cy="0"/>
+        </a:xfrm>
+      </p:grpSpPr>
       <p:sp>
         <p:nvSpPr>
           <p:cNvPr id="2" name="Rectangle 1"/>
@@ -5938,6 +5981,7 @@
           <a:lstStyle/>
           <a:p>
             <a:pPr algn="ctr"/>
+            <a:endParaRPr/>
           </a:p>
         </p:txBody>
       </p:sp>
@@ -6051,6 +6095,7 @@
           <a:lstStyle/>
           <a:p>
             <a:pPr algn="ctr"/>
+            <a:endParaRPr/>
           </a:p>
         </p:txBody>
       </p:sp>
@@ -6094,6 +6139,7 @@
           <a:lstStyle/>
           <a:p>
             <a:pPr algn="ctr"/>
+            <a:endParaRPr/>
           </a:p>
         </p:txBody>
       </p:sp>
@@ -6137,6 +6183,7 @@
           <a:lstStyle/>
           <a:p>
             <a:pPr algn="ctr"/>
+            <a:endParaRPr/>
           </a:p>
         </p:txBody>
       </p:sp>
@@ -6157,7 +6204,7 @@
           <a:noFill/>
         </p:spPr>
         <p:txBody>
-          <a:bodyPr wrap="square" lIns="0" rIns="0" tIns="0" bIns="0" anchor="t">
+          <a:bodyPr wrap="square" lIns="0" tIns="0" rIns="0" bIns="0" anchor="t">
             <a:spAutoFit/>
           </a:bodyPr>
           <a:lstStyle/>
@@ -6237,7 +6284,7 @@
           <a:noFill/>
         </p:spPr>
         <p:txBody>
-          <a:bodyPr wrap="square" lIns="0" rIns="0" tIns="0" bIns="0" anchor="t">
+          <a:bodyPr wrap="square" lIns="0" tIns="0" rIns="0" bIns="0" anchor="t">
             <a:spAutoFit/>
           </a:bodyPr>
           <a:lstStyle/>
@@ -6282,7 +6329,7 @@
           <a:noFill/>
         </p:spPr>
         <p:txBody>
-          <a:bodyPr wrap="square" lIns="0" rIns="0" tIns="0" bIns="0" anchor="t">
+          <a:bodyPr wrap="square" lIns="0" tIns="0" rIns="0" bIns="0" anchor="t">
             <a:spAutoFit/>
           </a:bodyPr>
           <a:lstStyle/>
@@ -6352,6 +6399,7 @@
           <a:lstStyle/>
           <a:p>
             <a:pPr algn="ctr"/>
+            <a:endParaRPr/>
           </a:p>
         </p:txBody>
       </p:sp>
@@ -6372,7 +6420,7 @@
           <a:noFill/>
         </p:spPr>
         <p:txBody>
-          <a:bodyPr wrap="square" lIns="0" rIns="0" tIns="0" bIns="0" anchor="t">
+          <a:bodyPr wrap="square" lIns="0" tIns="0" rIns="0" bIns="0" anchor="t">
             <a:spAutoFit/>
           </a:bodyPr>
           <a:lstStyle/>
@@ -6417,7 +6465,7 @@
           <a:noFill/>
         </p:spPr>
         <p:txBody>
-          <a:bodyPr wrap="square" lIns="0" rIns="0" tIns="0" bIns="0" anchor="t">
+          <a:bodyPr wrap="square" lIns="0" tIns="0" rIns="0" bIns="0" anchor="t">
             <a:spAutoFit/>
           </a:bodyPr>
           <a:lstStyle/>
@@ -6497,7 +6545,7 @@
           <a:noFill/>
         </p:spPr>
         <p:txBody>
-          <a:bodyPr wrap="square" lIns="0" rIns="0" tIns="0" bIns="0" anchor="t">
+          <a:bodyPr wrap="square" lIns="0" tIns="0" rIns="0" bIns="0" anchor="t">
             <a:spAutoFit/>
           </a:bodyPr>
           <a:lstStyle/>
@@ -6542,7 +6590,7 @@
           <a:noFill/>
         </p:spPr>
         <p:txBody>
-          <a:bodyPr wrap="square" lIns="0" rIns="0" tIns="0" bIns="0" anchor="t">
+          <a:bodyPr wrap="square" lIns="0" tIns="0" rIns="0" bIns="0" anchor="t">
             <a:spAutoFit/>
           </a:bodyPr>
           <a:lstStyle/>
@@ -6579,7 +6627,7 @@
 </file>
 
 <file path=ppt/slides/slide2.xml><?xml version="1.0" encoding="utf-8"?>
-<p:sld xmlns:a="http://schemas.openxmlformats.org/drawingml/2006/main" xmlns:p="http://schemas.openxmlformats.org/presentationml/2006/main" xmlns:r="http://schemas.openxmlformats.org/officeDocument/2006/relationships">
+<p:sld xmlns:a="http://schemas.openxmlformats.org/drawingml/2006/main" xmlns:r="http://schemas.openxmlformats.org/officeDocument/2006/relationships" xmlns:p="http://schemas.openxmlformats.org/presentationml/2006/main">
   <p:cSld>
     <p:bg>
       <p:bgPr>
@@ -6595,7 +6643,14 @@
         <p:cNvGrpSpPr/>
         <p:nvPr/>
       </p:nvGrpSpPr>
-      <p:grpSpPr/>
+      <p:grpSpPr>
+        <a:xfrm>
+          <a:off x="0" y="0"/>
+          <a:ext cx="0" cy="0"/>
+          <a:chOff x="0" y="0"/>
+          <a:chExt cx="0" cy="0"/>
+        </a:xfrm>
+      </p:grpSpPr>
       <p:cxnSp>
         <p:nvCxnSpPr>
           <p:cNvPr id="2" name="Connector 1"/>
@@ -6706,6 +6761,7 @@
           <a:lstStyle/>
           <a:p>
             <a:pPr algn="ctr"/>
+            <a:endParaRPr/>
           </a:p>
         </p:txBody>
       </p:sp>
@@ -6749,6 +6805,7 @@
           <a:lstStyle/>
           <a:p>
             <a:pPr algn="ctr"/>
+            <a:endParaRPr/>
           </a:p>
         </p:txBody>
       </p:sp>
@@ -6792,6 +6849,7 @@
           <a:lstStyle/>
           <a:p>
             <a:pPr algn="ctr"/>
+            <a:endParaRPr/>
           </a:p>
         </p:txBody>
       </p:sp>
@@ -6812,7 +6870,7 @@
           <a:noFill/>
         </p:spPr>
         <p:txBody>
-          <a:bodyPr wrap="square" lIns="0" rIns="0" tIns="0" bIns="0" anchor="t">
+          <a:bodyPr wrap="square" lIns="0" tIns="0" rIns="0" bIns="0" anchor="t">
             <a:spAutoFit/>
           </a:bodyPr>
           <a:lstStyle/>
@@ -6857,7 +6915,7 @@
           <a:noFill/>
         </p:spPr>
         <p:txBody>
-          <a:bodyPr wrap="square" lIns="0" rIns="0" tIns="0" bIns="0" anchor="t">
+          <a:bodyPr wrap="square" lIns="0" tIns="0" rIns="0" bIns="0" anchor="t">
             <a:spAutoFit/>
           </a:bodyPr>
           <a:lstStyle/>
@@ -6937,7 +6995,7 @@
           <a:noFill/>
         </p:spPr>
         <p:txBody>
-          <a:bodyPr wrap="square" lIns="0" rIns="0" tIns="0" bIns="0" anchor="t">
+          <a:bodyPr wrap="square" lIns="0" tIns="0" rIns="0" bIns="0" anchor="t">
             <a:spAutoFit/>
           </a:bodyPr>
           <a:lstStyle/>
@@ -6982,7 +7040,7 @@
           <a:noFill/>
         </p:spPr>
         <p:txBody>
-          <a:bodyPr wrap="square" lIns="0" rIns="0" tIns="0" bIns="0" anchor="t">
+          <a:bodyPr wrap="square" lIns="0" tIns="0" rIns="0" bIns="0" anchor="t">
             <a:spAutoFit/>
           </a:bodyPr>
           <a:lstStyle/>
@@ -7027,7 +7085,7 @@
           <a:noFill/>
         </p:spPr>
         <p:txBody>
-          <a:bodyPr wrap="square" lIns="0" rIns="0" tIns="0" bIns="0" anchor="t">
+          <a:bodyPr wrap="square" lIns="0" tIns="0" rIns="0" bIns="0" anchor="t">
             <a:spAutoFit/>
           </a:bodyPr>
           <a:lstStyle/>
@@ -7095,6 +7153,7 @@
           <a:lstStyle/>
           <a:p>
             <a:pPr algn="ctr"/>
+            <a:endParaRPr/>
           </a:p>
         </p:txBody>
       </p:sp>
@@ -7138,6 +7197,7 @@
           <a:lstStyle/>
           <a:p>
             <a:pPr algn="ctr"/>
+            <a:endParaRPr/>
           </a:p>
         </p:txBody>
       </p:sp>
@@ -7181,6 +7241,7 @@
           <a:lstStyle/>
           <a:p>
             <a:pPr algn="ctr"/>
+            <a:endParaRPr/>
           </a:p>
         </p:txBody>
       </p:sp>
@@ -7224,6 +7285,7 @@
           <a:lstStyle/>
           <a:p>
             <a:pPr algn="ctr"/>
+            <a:endParaRPr/>
           </a:p>
         </p:txBody>
       </p:sp>
@@ -7267,6 +7329,7 @@
           <a:lstStyle/>
           <a:p>
             <a:pPr algn="ctr"/>
+            <a:endParaRPr/>
           </a:p>
         </p:txBody>
       </p:sp>
@@ -7310,6 +7373,7 @@
           <a:lstStyle/>
           <a:p>
             <a:pPr algn="ctr"/>
+            <a:endParaRPr/>
           </a:p>
         </p:txBody>
       </p:sp>
@@ -7353,6 +7417,7 @@
           <a:lstStyle/>
           <a:p>
             <a:pPr algn="ctr"/>
+            <a:endParaRPr/>
           </a:p>
         </p:txBody>
       </p:sp>
@@ -7396,6 +7461,7 @@
           <a:lstStyle/>
           <a:p>
             <a:pPr algn="ctr"/>
+            <a:endParaRPr/>
           </a:p>
         </p:txBody>
       </p:sp>
@@ -7439,6 +7505,7 @@
           <a:lstStyle/>
           <a:p>
             <a:pPr algn="ctr"/>
+            <a:endParaRPr/>
           </a:p>
         </p:txBody>
       </p:sp>
@@ -7482,6 +7549,7 @@
           <a:lstStyle/>
           <a:p>
             <a:pPr algn="ctr"/>
+            <a:endParaRPr/>
           </a:p>
         </p:txBody>
       </p:sp>
@@ -7525,6 +7593,7 @@
           <a:lstStyle/>
           <a:p>
             <a:pPr algn="ctr"/>
+            <a:endParaRPr/>
           </a:p>
         </p:txBody>
       </p:sp>
@@ -7545,7 +7614,7 @@
           <a:noFill/>
         </p:spPr>
         <p:txBody>
-          <a:bodyPr wrap="square" lIns="0" rIns="0" tIns="0" bIns="0" anchor="t">
+          <a:bodyPr wrap="square" lIns="0" tIns="0" rIns="0" bIns="0" anchor="t">
             <a:spAutoFit/>
           </a:bodyPr>
           <a:lstStyle/>
@@ -7590,7 +7659,7 @@
           <a:noFill/>
         </p:spPr>
         <p:txBody>
-          <a:bodyPr wrap="square" lIns="0" rIns="0" tIns="0" bIns="0" anchor="t">
+          <a:bodyPr wrap="square" lIns="0" tIns="0" rIns="0" bIns="0" anchor="t">
             <a:spAutoFit/>
           </a:bodyPr>
           <a:lstStyle/>
@@ -7662,6 +7731,7 @@
           <a:lstStyle/>
           <a:p>
             <a:pPr algn="ctr"/>
+            <a:endParaRPr/>
           </a:p>
         </p:txBody>
       </p:sp>
@@ -7682,7 +7752,7 @@
           <a:noFill/>
         </p:spPr>
         <p:txBody>
-          <a:bodyPr wrap="square" lIns="0" rIns="0" tIns="0" bIns="0" anchor="t">
+          <a:bodyPr wrap="square" lIns="0" tIns="0" rIns="0" bIns="0" anchor="t">
             <a:spAutoFit/>
           </a:bodyPr>
           <a:lstStyle/>
@@ -7727,7 +7797,7 @@
           <a:noFill/>
         </p:spPr>
         <p:txBody>
-          <a:bodyPr wrap="square" lIns="0" rIns="0" tIns="0" bIns="0" anchor="t">
+          <a:bodyPr wrap="square" lIns="0" tIns="0" rIns="0" bIns="0" anchor="t">
             <a:spAutoFit/>
           </a:bodyPr>
           <a:lstStyle/>
@@ -7817,6 +7887,7 @@
           <a:lstStyle/>
           <a:p>
             <a:pPr algn="ctr"/>
+            <a:endParaRPr/>
           </a:p>
         </p:txBody>
       </p:sp>
@@ -7837,7 +7908,7 @@
           <a:noFill/>
         </p:spPr>
         <p:txBody>
-          <a:bodyPr wrap="square" lIns="0" rIns="0" tIns="0" bIns="0" anchor="t">
+          <a:bodyPr wrap="square" lIns="0" tIns="0" rIns="0" bIns="0" anchor="t">
             <a:spAutoFit/>
           </a:bodyPr>
           <a:lstStyle/>
@@ -7882,7 +7953,7 @@
           <a:noFill/>
         </p:spPr>
         <p:txBody>
-          <a:bodyPr wrap="square" lIns="0" rIns="0" tIns="0" bIns="0" anchor="t">
+          <a:bodyPr wrap="square" lIns="0" tIns="0" rIns="0" bIns="0" anchor="t">
             <a:spAutoFit/>
           </a:bodyPr>
           <a:lstStyle/>
@@ -7927,7 +7998,7 @@
           <a:noFill/>
         </p:spPr>
         <p:txBody>
-          <a:bodyPr wrap="square" lIns="0" rIns="0" tIns="0" bIns="0" anchor="t">
+          <a:bodyPr wrap="square" lIns="0" tIns="0" rIns="0" bIns="0" anchor="t">
             <a:spAutoFit/>
           </a:bodyPr>
           <a:lstStyle/>
@@ -7995,6 +8066,7 @@
           <a:lstStyle/>
           <a:p>
             <a:pPr algn="ctr"/>
+            <a:endParaRPr/>
           </a:p>
         </p:txBody>
       </p:sp>
@@ -8015,7 +8087,7 @@
           <a:noFill/>
         </p:spPr>
         <p:txBody>
-          <a:bodyPr wrap="square" lIns="0" rIns="0" tIns="0" bIns="0" anchor="t">
+          <a:bodyPr wrap="square" lIns="0" tIns="0" rIns="0" bIns="0" anchor="t">
             <a:spAutoFit/>
           </a:bodyPr>
           <a:lstStyle/>
@@ -8060,7 +8132,7 @@
           <a:noFill/>
         </p:spPr>
         <p:txBody>
-          <a:bodyPr wrap="square" lIns="0" rIns="0" tIns="0" bIns="0" anchor="t">
+          <a:bodyPr wrap="square" lIns="0" tIns="0" rIns="0" bIns="0" anchor="t">
             <a:spAutoFit/>
           </a:bodyPr>
           <a:lstStyle/>
@@ -8105,7 +8177,7 @@
           <a:noFill/>
         </p:spPr>
         <p:txBody>
-          <a:bodyPr wrap="square" lIns="0" rIns="0" tIns="0" bIns="0" anchor="t">
+          <a:bodyPr wrap="square" lIns="0" tIns="0" rIns="0" bIns="0" anchor="t">
             <a:spAutoFit/>
           </a:bodyPr>
           <a:lstStyle/>
@@ -8173,6 +8245,7 @@
           <a:lstStyle/>
           <a:p>
             <a:pPr algn="ctr"/>
+            <a:endParaRPr/>
           </a:p>
         </p:txBody>
       </p:sp>
@@ -8193,7 +8266,7 @@
           <a:noFill/>
         </p:spPr>
         <p:txBody>
-          <a:bodyPr wrap="square" lIns="0" rIns="0" tIns="0" bIns="0" anchor="t">
+          <a:bodyPr wrap="square" lIns="0" tIns="0" rIns="0" bIns="0" anchor="t">
             <a:spAutoFit/>
           </a:bodyPr>
           <a:lstStyle/>
@@ -8238,7 +8311,7 @@
           <a:noFill/>
         </p:spPr>
         <p:txBody>
-          <a:bodyPr wrap="square" lIns="0" rIns="0" tIns="0" bIns="0" anchor="t">
+          <a:bodyPr wrap="square" lIns="0" tIns="0" rIns="0" bIns="0" anchor="t">
             <a:spAutoFit/>
           </a:bodyPr>
           <a:lstStyle/>
@@ -8283,7 +8356,7 @@
           <a:noFill/>
         </p:spPr>
         <p:txBody>
-          <a:bodyPr wrap="square" lIns="0" rIns="0" tIns="0" bIns="0" anchor="t">
+          <a:bodyPr wrap="square" lIns="0" tIns="0" rIns="0" bIns="0" anchor="t">
             <a:spAutoFit/>
           </a:bodyPr>
           <a:lstStyle/>
@@ -8320,7 +8393,7 @@
 </file>
 
 <file path=ppt/slides/slide3.xml><?xml version="1.0" encoding="utf-8"?>
-<p:sld xmlns:a="http://schemas.openxmlformats.org/drawingml/2006/main" xmlns:p="http://schemas.openxmlformats.org/presentationml/2006/main" xmlns:r="http://schemas.openxmlformats.org/officeDocument/2006/relationships">
+<p:sld xmlns:a="http://schemas.openxmlformats.org/drawingml/2006/main" xmlns:r="http://schemas.openxmlformats.org/officeDocument/2006/relationships" xmlns:p="http://schemas.openxmlformats.org/presentationml/2006/main">
   <p:cSld>
     <p:bg>
       <p:bgPr>
@@ -8336,7 +8409,14 @@
         <p:cNvGrpSpPr/>
         <p:nvPr/>
       </p:nvGrpSpPr>
-      <p:grpSpPr/>
+      <p:grpSpPr>
+        <a:xfrm>
+          <a:off x="0" y="0"/>
+          <a:ext cx="0" cy="0"/>
+          <a:chOff x="0" y="0"/>
+          <a:chExt cx="0" cy="0"/>
+        </a:xfrm>
+      </p:grpSpPr>
       <p:cxnSp>
         <p:nvCxnSpPr>
           <p:cNvPr id="2" name="Connector 1"/>
@@ -8447,6 +8527,7 @@
           <a:lstStyle/>
           <a:p>
             <a:pPr algn="ctr"/>
+            <a:endParaRPr/>
           </a:p>
         </p:txBody>
       </p:sp>
@@ -8490,6 +8571,7 @@
           <a:lstStyle/>
           <a:p>
             <a:pPr algn="ctr"/>
+            <a:endParaRPr/>
           </a:p>
         </p:txBody>
       </p:sp>
@@ -8533,6 +8615,7 @@
           <a:lstStyle/>
           <a:p>
             <a:pPr algn="ctr"/>
+            <a:endParaRPr/>
           </a:p>
         </p:txBody>
       </p:sp>
@@ -8553,7 +8636,7 @@
           <a:noFill/>
         </p:spPr>
         <p:txBody>
-          <a:bodyPr wrap="square" lIns="0" rIns="0" tIns="0" bIns="0" anchor="t">
+          <a:bodyPr wrap="square" lIns="0" tIns="0" rIns="0" bIns="0" anchor="t">
             <a:spAutoFit/>
           </a:bodyPr>
           <a:lstStyle/>
@@ -8598,7 +8681,7 @@
           <a:noFill/>
         </p:spPr>
         <p:txBody>
-          <a:bodyPr wrap="square" lIns="0" rIns="0" tIns="0" bIns="0" anchor="t">
+          <a:bodyPr wrap="square" lIns="0" tIns="0" rIns="0" bIns="0" anchor="t">
             <a:spAutoFit/>
           </a:bodyPr>
           <a:lstStyle/>
@@ -8678,7 +8761,7 @@
           <a:noFill/>
         </p:spPr>
         <p:txBody>
-          <a:bodyPr wrap="square" lIns="0" rIns="0" tIns="0" bIns="0" anchor="t">
+          <a:bodyPr wrap="square" lIns="0" tIns="0" rIns="0" bIns="0" anchor="t">
             <a:spAutoFit/>
           </a:bodyPr>
           <a:lstStyle/>
@@ -8723,7 +8806,7 @@
           <a:noFill/>
         </p:spPr>
         <p:txBody>
-          <a:bodyPr wrap="square" lIns="0" rIns="0" tIns="0" bIns="0" anchor="t">
+          <a:bodyPr wrap="square" lIns="0" tIns="0" rIns="0" bIns="0" anchor="t">
             <a:spAutoFit/>
           </a:bodyPr>
           <a:lstStyle/>
@@ -8768,7 +8851,7 @@
           <a:noFill/>
         </p:spPr>
         <p:txBody>
-          <a:bodyPr wrap="square" lIns="0" rIns="0" tIns="0" bIns="0" anchor="t">
+          <a:bodyPr wrap="square" lIns="0" tIns="0" rIns="0" bIns="0" anchor="t">
             <a:spAutoFit/>
           </a:bodyPr>
           <a:lstStyle/>
@@ -8836,6 +8919,7 @@
           <a:lstStyle/>
           <a:p>
             <a:pPr algn="ctr"/>
+            <a:endParaRPr/>
           </a:p>
         </p:txBody>
       </p:sp>
@@ -8879,6 +8963,7 @@
           <a:lstStyle/>
           <a:p>
             <a:pPr algn="ctr"/>
+            <a:endParaRPr/>
           </a:p>
         </p:txBody>
       </p:sp>
@@ -8922,6 +9007,7 @@
           <a:lstStyle/>
           <a:p>
             <a:pPr algn="ctr"/>
+            <a:endParaRPr/>
           </a:p>
         </p:txBody>
       </p:sp>
@@ -8965,6 +9051,7 @@
           <a:lstStyle/>
           <a:p>
             <a:pPr algn="ctr"/>
+            <a:endParaRPr/>
           </a:p>
         </p:txBody>
       </p:sp>
@@ -9008,6 +9095,7 @@
           <a:lstStyle/>
           <a:p>
             <a:pPr algn="ctr"/>
+            <a:endParaRPr/>
           </a:p>
         </p:txBody>
       </p:sp>
@@ -9051,6 +9139,7 @@
           <a:lstStyle/>
           <a:p>
             <a:pPr algn="ctr"/>
+            <a:endParaRPr/>
           </a:p>
         </p:txBody>
       </p:sp>
@@ -9094,6 +9183,7 @@
           <a:lstStyle/>
           <a:p>
             <a:pPr algn="ctr"/>
+            <a:endParaRPr/>
           </a:p>
         </p:txBody>
       </p:sp>
@@ -9137,6 +9227,7 @@
           <a:lstStyle/>
           <a:p>
             <a:pPr algn="ctr"/>
+            <a:endParaRPr/>
           </a:p>
         </p:txBody>
       </p:sp>
@@ -9180,6 +9271,7 @@
           <a:lstStyle/>
           <a:p>
             <a:pPr algn="ctr"/>
+            <a:endParaRPr/>
           </a:p>
         </p:txBody>
       </p:sp>
@@ -9223,6 +9315,7 @@
           <a:lstStyle/>
           <a:p>
             <a:pPr algn="ctr"/>
+            <a:endParaRPr/>
           </a:p>
         </p:txBody>
       </p:sp>
@@ -9266,6 +9359,7 @@
           <a:lstStyle/>
           <a:p>
             <a:pPr algn="ctr"/>
+            <a:endParaRPr/>
           </a:p>
         </p:txBody>
       </p:sp>
@@ -9286,7 +9380,7 @@
           <a:noFill/>
         </p:spPr>
         <p:txBody>
-          <a:bodyPr wrap="square" lIns="0" rIns="0" tIns="0" bIns="0" anchor="t">
+          <a:bodyPr wrap="square" lIns="0" tIns="0" rIns="0" bIns="0" anchor="t">
             <a:spAutoFit/>
           </a:bodyPr>
           <a:lstStyle/>
@@ -9331,7 +9425,7 @@
           <a:noFill/>
         </p:spPr>
         <p:txBody>
-          <a:bodyPr wrap="square" lIns="0" rIns="0" tIns="0" bIns="0" anchor="t">
+          <a:bodyPr wrap="square" lIns="0" tIns="0" rIns="0" bIns="0" anchor="t">
             <a:spAutoFit/>
           </a:bodyPr>
           <a:lstStyle/>
@@ -9368,7 +9462,7 @@
         <p:spPr>
           <a:xfrm>
             <a:off x="795528" y="2980944"/>
-            <a:ext cx="3657600" cy="228600"/>
+            <a:ext cx="3657600" cy="276999"/>
           </a:xfrm>
           <a:prstGeom prst="rect">
             <a:avLst/>
@@ -9376,7 +9470,7 @@
           <a:noFill/>
         </p:spPr>
         <p:txBody>
-          <a:bodyPr wrap="square" lIns="0" rIns="0" tIns="0" bIns="0" anchor="t">
+          <a:bodyPr wrap="square" lIns="0" tIns="0" rIns="0" bIns="0" anchor="t">
             <a:spAutoFit/>
           </a:bodyPr>
           <a:lstStyle/>
@@ -9393,7 +9487,7 @@
               </a:spcAft>
             </a:pPr>
             <a:r>
-              <a:rPr sz="1000" b="1">
+              <a:rPr b="1" dirty="0">
                 <a:solidFill>
                   <a:srgbClr val="55D6CA"/>
                 </a:solidFill>
@@ -9421,7 +9515,7 @@
           <a:noFill/>
         </p:spPr>
         <p:txBody>
-          <a:bodyPr wrap="square" lIns="0" rIns="0" tIns="0" bIns="0" anchor="t">
+          <a:bodyPr wrap="square" lIns="0" tIns="0" rIns="0" bIns="0" anchor="t">
             <a:spAutoFit/>
           </a:bodyPr>
           <a:lstStyle/>
@@ -9466,7 +9560,7 @@
           <a:noFill/>
         </p:spPr>
         <p:txBody>
-          <a:bodyPr wrap="square" lIns="0" rIns="0" tIns="0" bIns="0" anchor="t">
+          <a:bodyPr wrap="square" lIns="0" tIns="0" rIns="0" bIns="0" anchor="t">
             <a:spAutoFit/>
           </a:bodyPr>
           <a:lstStyle/>
@@ -9538,7 +9632,7 @@
         <p:spPr>
           <a:xfrm>
             <a:off x="6519672" y="3063240"/>
-            <a:ext cx="3657600" cy="228600"/>
+            <a:ext cx="3657600" cy="184666"/>
           </a:xfrm>
           <a:prstGeom prst="rect">
             <a:avLst/>
@@ -9546,7 +9640,7 @@
           <a:noFill/>
         </p:spPr>
         <p:txBody>
-          <a:bodyPr wrap="square" lIns="0" rIns="0" tIns="0" bIns="0" anchor="t">
+          <a:bodyPr wrap="square" lIns="0" tIns="0" rIns="0" bIns="0" anchor="t">
             <a:spAutoFit/>
           </a:bodyPr>
           <a:lstStyle/>
@@ -9563,7 +9657,7 @@
               </a:spcAft>
             </a:pPr>
             <a:r>
-              <a:rPr sz="1000" b="1">
+              <a:rPr sz="1200" b="1" dirty="0">
                 <a:solidFill>
                   <a:srgbClr val="55D6CA"/>
                 </a:solidFill>
@@ -9591,7 +9685,7 @@
           <a:noFill/>
         </p:spPr>
         <p:txBody>
-          <a:bodyPr wrap="square" lIns="0" rIns="0" tIns="0" bIns="0" anchor="t">
+          <a:bodyPr wrap="square" lIns="0" tIns="0" rIns="0" bIns="0" anchor="t">
             <a:spAutoFit/>
           </a:bodyPr>
           <a:lstStyle/>
@@ -9628,7 +9722,7 @@
         <p:spPr>
           <a:xfrm>
             <a:off x="9290304" y="3063240"/>
-            <a:ext cx="3657600" cy="228600"/>
+            <a:ext cx="3657600" cy="184666"/>
           </a:xfrm>
           <a:prstGeom prst="rect">
             <a:avLst/>
@@ -9636,7 +9730,7 @@
           <a:noFill/>
         </p:spPr>
         <p:txBody>
-          <a:bodyPr wrap="square" lIns="0" rIns="0" tIns="0" bIns="0" anchor="t">
+          <a:bodyPr wrap="square" lIns="0" tIns="0" rIns="0" bIns="0" anchor="t">
             <a:spAutoFit/>
           </a:bodyPr>
           <a:lstStyle/>
@@ -9653,7 +9747,7 @@
               </a:spcAft>
             </a:pPr>
             <a:r>
-              <a:rPr sz="1000" b="1">
+              <a:rPr sz="1200" b="1">
                 <a:solidFill>
                   <a:srgbClr val="55D6CA"/>
                 </a:solidFill>
@@ -9681,7 +9775,7 @@
           <a:noFill/>
         </p:spPr>
         <p:txBody>
-          <a:bodyPr wrap="square" lIns="0" rIns="0" tIns="0" bIns="0" anchor="t">
+          <a:bodyPr wrap="square" lIns="0" tIns="0" rIns="0" bIns="0" anchor="t">
             <a:spAutoFit/>
           </a:bodyPr>
           <a:lstStyle/>
@@ -9761,7 +9855,7 @@
           <a:noFill/>
         </p:spPr>
         <p:txBody>
-          <a:bodyPr wrap="square" lIns="0" rIns="0" tIns="0" bIns="0" anchor="t">
+          <a:bodyPr wrap="square" lIns="0" tIns="0" rIns="0" bIns="0" anchor="t">
             <a:spAutoFit/>
           </a:bodyPr>
           <a:lstStyle/>
@@ -9806,7 +9900,7 @@
           <a:noFill/>
         </p:spPr>
         <p:txBody>
-          <a:bodyPr wrap="square" lIns="0" rIns="0" tIns="0" bIns="0" anchor="t">
+          <a:bodyPr wrap="square" lIns="0" tIns="0" rIns="0" bIns="0" anchor="t">
             <a:spAutoFit/>
           </a:bodyPr>
           <a:lstStyle/>
@@ -9843,7 +9937,7 @@
 </file>
 
 <file path=ppt/slides/slide4.xml><?xml version="1.0" encoding="utf-8"?>
-<p:sld xmlns:a="http://schemas.openxmlformats.org/drawingml/2006/main" xmlns:p="http://schemas.openxmlformats.org/presentationml/2006/main" xmlns:r="http://schemas.openxmlformats.org/officeDocument/2006/relationships">
+<p:sld xmlns:a="http://schemas.openxmlformats.org/drawingml/2006/main" xmlns:r="http://schemas.openxmlformats.org/officeDocument/2006/relationships" xmlns:p="http://schemas.openxmlformats.org/presentationml/2006/main">
   <p:cSld>
     <p:bg>
       <p:bgPr>
@@ -9859,7 +9953,14 @@
         <p:cNvGrpSpPr/>
         <p:nvPr/>
       </p:nvGrpSpPr>
-      <p:grpSpPr/>
+      <p:grpSpPr>
+        <a:xfrm>
+          <a:off x="0" y="0"/>
+          <a:ext cx="0" cy="0"/>
+          <a:chOff x="0" y="0"/>
+          <a:chExt cx="0" cy="0"/>
+        </a:xfrm>
+      </p:grpSpPr>
       <p:cxnSp>
         <p:nvCxnSpPr>
           <p:cNvPr id="2" name="Connector 1"/>
@@ -9970,6 +10071,7 @@
           <a:lstStyle/>
           <a:p>
             <a:pPr algn="ctr"/>
+            <a:endParaRPr/>
           </a:p>
         </p:txBody>
       </p:sp>
@@ -10013,6 +10115,7 @@
           <a:lstStyle/>
           <a:p>
             <a:pPr algn="ctr"/>
+            <a:endParaRPr/>
           </a:p>
         </p:txBody>
       </p:sp>
@@ -10056,6 +10159,7 @@
           <a:lstStyle/>
           <a:p>
             <a:pPr algn="ctr"/>
+            <a:endParaRPr/>
           </a:p>
         </p:txBody>
       </p:sp>
@@ -10076,7 +10180,7 @@
           <a:noFill/>
         </p:spPr>
         <p:txBody>
-          <a:bodyPr wrap="square" lIns="0" rIns="0" tIns="0" bIns="0" anchor="t">
+          <a:bodyPr wrap="square" lIns="0" tIns="0" rIns="0" bIns="0" anchor="t">
             <a:spAutoFit/>
           </a:bodyPr>
           <a:lstStyle/>
@@ -10121,7 +10225,7 @@
           <a:noFill/>
         </p:spPr>
         <p:txBody>
-          <a:bodyPr wrap="square" lIns="0" rIns="0" tIns="0" bIns="0" anchor="t">
+          <a:bodyPr wrap="square" lIns="0" tIns="0" rIns="0" bIns="0" anchor="t">
             <a:spAutoFit/>
           </a:bodyPr>
           <a:lstStyle/>
@@ -10201,7 +10305,7 @@
           <a:noFill/>
         </p:spPr>
         <p:txBody>
-          <a:bodyPr wrap="square" lIns="0" rIns="0" tIns="0" bIns="0" anchor="t">
+          <a:bodyPr wrap="square" lIns="0" tIns="0" rIns="0" bIns="0" anchor="t">
             <a:spAutoFit/>
           </a:bodyPr>
           <a:lstStyle/>
@@ -10246,7 +10350,7 @@
           <a:noFill/>
         </p:spPr>
         <p:txBody>
-          <a:bodyPr wrap="square" lIns="0" rIns="0" tIns="0" bIns="0" anchor="t">
+          <a:bodyPr wrap="square" lIns="0" tIns="0" rIns="0" bIns="0" anchor="t">
             <a:spAutoFit/>
           </a:bodyPr>
           <a:lstStyle/>
@@ -10291,7 +10395,7 @@
           <a:noFill/>
         </p:spPr>
         <p:txBody>
-          <a:bodyPr wrap="square" lIns="0" rIns="0" tIns="0" bIns="0" anchor="t">
+          <a:bodyPr wrap="square" lIns="0" tIns="0" rIns="0" bIns="0" anchor="t">
             <a:spAutoFit/>
           </a:bodyPr>
           <a:lstStyle/>
@@ -10359,6 +10463,7 @@
           <a:lstStyle/>
           <a:p>
             <a:pPr algn="ctr"/>
+            <a:endParaRPr/>
           </a:p>
         </p:txBody>
       </p:sp>
@@ -10402,6 +10507,7 @@
           <a:lstStyle/>
           <a:p>
             <a:pPr algn="ctr"/>
+            <a:endParaRPr/>
           </a:p>
         </p:txBody>
       </p:sp>
@@ -10445,6 +10551,7 @@
           <a:lstStyle/>
           <a:p>
             <a:pPr algn="ctr"/>
+            <a:endParaRPr/>
           </a:p>
         </p:txBody>
       </p:sp>
@@ -10488,6 +10595,7 @@
           <a:lstStyle/>
           <a:p>
             <a:pPr algn="ctr"/>
+            <a:endParaRPr/>
           </a:p>
         </p:txBody>
       </p:sp>
@@ -10531,6 +10639,7 @@
           <a:lstStyle/>
           <a:p>
             <a:pPr algn="ctr"/>
+            <a:endParaRPr/>
           </a:p>
         </p:txBody>
       </p:sp>
@@ -10574,6 +10683,7 @@
           <a:lstStyle/>
           <a:p>
             <a:pPr algn="ctr"/>
+            <a:endParaRPr/>
           </a:p>
         </p:txBody>
       </p:sp>
@@ -10617,6 +10727,7 @@
           <a:lstStyle/>
           <a:p>
             <a:pPr algn="ctr"/>
+            <a:endParaRPr/>
           </a:p>
         </p:txBody>
       </p:sp>
@@ -10660,6 +10771,7 @@
           <a:lstStyle/>
           <a:p>
             <a:pPr algn="ctr"/>
+            <a:endParaRPr/>
           </a:p>
         </p:txBody>
       </p:sp>
@@ -10703,6 +10815,7 @@
           <a:lstStyle/>
           <a:p>
             <a:pPr algn="ctr"/>
+            <a:endParaRPr/>
           </a:p>
         </p:txBody>
       </p:sp>
@@ -10746,6 +10859,7 @@
           <a:lstStyle/>
           <a:p>
             <a:pPr algn="ctr"/>
+            <a:endParaRPr/>
           </a:p>
         </p:txBody>
       </p:sp>
@@ -10789,6 +10903,7 @@
           <a:lstStyle/>
           <a:p>
             <a:pPr algn="ctr"/>
+            <a:endParaRPr/>
           </a:p>
         </p:txBody>
       </p:sp>
@@ -10809,7 +10924,7 @@
           <a:noFill/>
         </p:spPr>
         <p:txBody>
-          <a:bodyPr wrap="square" lIns="0" rIns="0" tIns="0" bIns="0" anchor="t">
+          <a:bodyPr wrap="square" lIns="0" tIns="0" rIns="0" bIns="0" anchor="t">
             <a:spAutoFit/>
           </a:bodyPr>
           <a:lstStyle/>
@@ -10854,7 +10969,7 @@
           <a:noFill/>
         </p:spPr>
         <p:txBody>
-          <a:bodyPr wrap="square" lIns="0" rIns="0" tIns="0" bIns="0" anchor="t">
+          <a:bodyPr wrap="square" lIns="0" tIns="0" rIns="0" bIns="0" anchor="t">
             <a:spAutoFit/>
           </a:bodyPr>
           <a:lstStyle/>
@@ -10899,7 +11014,7 @@
           <a:noFill/>
         </p:spPr>
         <p:txBody>
-          <a:bodyPr wrap="square" lIns="0" rIns="0" tIns="0" bIns="0" anchor="t">
+          <a:bodyPr wrap="square" lIns="0" tIns="0" rIns="0" bIns="0" anchor="t">
             <a:spAutoFit/>
           </a:bodyPr>
           <a:lstStyle/>
@@ -10969,6 +11084,7 @@
           <a:lstStyle/>
           <a:p>
             <a:pPr algn="ctr"/>
+            <a:endParaRPr/>
           </a:p>
         </p:txBody>
       </p:sp>
@@ -11014,6 +11130,7 @@
           <a:lstStyle/>
           <a:p>
             <a:pPr algn="ctr"/>
+            <a:endParaRPr/>
           </a:p>
         </p:txBody>
       </p:sp>
@@ -11034,7 +11151,7 @@
           <a:noFill/>
         </p:spPr>
         <p:txBody>
-          <a:bodyPr wrap="square" lIns="0" rIns="0" tIns="0" bIns="0" anchor="t">
+          <a:bodyPr wrap="square" lIns="0" tIns="0" rIns="0" bIns="0" anchor="t">
             <a:spAutoFit/>
           </a:bodyPr>
           <a:lstStyle/>
@@ -11079,7 +11196,7 @@
           <a:noFill/>
         </p:spPr>
         <p:txBody>
-          <a:bodyPr wrap="square" lIns="0" rIns="0" tIns="0" bIns="0" anchor="t">
+          <a:bodyPr wrap="square" lIns="0" tIns="0" rIns="0" bIns="0" anchor="t">
             <a:spAutoFit/>
           </a:bodyPr>
           <a:lstStyle/>
@@ -11149,6 +11266,7 @@
           <a:lstStyle/>
           <a:p>
             <a:pPr algn="ctr"/>
+            <a:endParaRPr/>
           </a:p>
         </p:txBody>
       </p:sp>
@@ -11194,6 +11312,7 @@
           <a:lstStyle/>
           <a:p>
             <a:pPr algn="ctr"/>
+            <a:endParaRPr/>
           </a:p>
         </p:txBody>
       </p:sp>
@@ -11214,7 +11333,7 @@
           <a:noFill/>
         </p:spPr>
         <p:txBody>
-          <a:bodyPr wrap="square" lIns="0" rIns="0" tIns="0" bIns="0" anchor="t">
+          <a:bodyPr wrap="square" lIns="0" tIns="0" rIns="0" bIns="0" anchor="t">
             <a:spAutoFit/>
           </a:bodyPr>
           <a:lstStyle/>
@@ -11259,7 +11378,7 @@
           <a:noFill/>
         </p:spPr>
         <p:txBody>
-          <a:bodyPr wrap="square" lIns="0" rIns="0" tIns="0" bIns="0" anchor="t">
+          <a:bodyPr wrap="square" lIns="0" tIns="0" rIns="0" bIns="0" anchor="t">
             <a:spAutoFit/>
           </a:bodyPr>
           <a:lstStyle/>
@@ -11329,6 +11448,7 @@
           <a:lstStyle/>
           <a:p>
             <a:pPr algn="ctr"/>
+            <a:endParaRPr/>
           </a:p>
         </p:txBody>
       </p:sp>
@@ -11374,6 +11494,7 @@
           <a:lstStyle/>
           <a:p>
             <a:pPr algn="ctr"/>
+            <a:endParaRPr/>
           </a:p>
         </p:txBody>
       </p:sp>
@@ -11394,7 +11515,7 @@
           <a:noFill/>
         </p:spPr>
         <p:txBody>
-          <a:bodyPr wrap="square" lIns="0" rIns="0" tIns="0" bIns="0" anchor="t">
+          <a:bodyPr wrap="square" lIns="0" tIns="0" rIns="0" bIns="0" anchor="t">
             <a:spAutoFit/>
           </a:bodyPr>
           <a:lstStyle/>
@@ -11464,6 +11585,7 @@
           <a:lstStyle/>
           <a:p>
             <a:pPr algn="ctr"/>
+            <a:endParaRPr/>
           </a:p>
         </p:txBody>
       </p:sp>
@@ -11476,7 +11598,7 @@
         <p:spPr>
           <a:xfrm>
             <a:off x="10076688" y="3291840"/>
-            <a:ext cx="1188720" cy="228600"/>
+            <a:ext cx="1188720" cy="215444"/>
           </a:xfrm>
           <a:prstGeom prst="rect">
             <a:avLst/>
@@ -11484,7 +11606,7 @@
           <a:noFill/>
         </p:spPr>
         <p:txBody>
-          <a:bodyPr wrap="square" lIns="0" rIns="0" tIns="0" bIns="0" anchor="t">
+          <a:bodyPr wrap="square" lIns="0" tIns="0" rIns="0" bIns="0" anchor="t">
             <a:spAutoFit/>
           </a:bodyPr>
           <a:lstStyle/>
@@ -11501,7 +11623,7 @@
               </a:spcAft>
             </a:pPr>
             <a:r>
-              <a:rPr sz="1000" b="1">
+              <a:rPr sz="1400" b="1" dirty="0">
                 <a:solidFill>
                   <a:srgbClr val="365BCF"/>
                 </a:solidFill>
@@ -11529,7 +11651,7 @@
           <a:noFill/>
         </p:spPr>
         <p:txBody>
-          <a:bodyPr wrap="square" lIns="0" rIns="0" tIns="0" bIns="0" anchor="t">
+          <a:bodyPr wrap="square" lIns="0" tIns="0" rIns="0" bIns="0" anchor="t">
             <a:spAutoFit/>
           </a:bodyPr>
           <a:lstStyle/>
@@ -11566,7 +11688,7 @@
         <p:spPr>
           <a:xfrm>
             <a:off x="10049256" y="4416552"/>
-            <a:ext cx="1097280" cy="320040"/>
+            <a:ext cx="1097280" cy="246221"/>
           </a:xfrm>
           <a:prstGeom prst="rect">
             <a:avLst/>
@@ -11574,7 +11696,7 @@
           <a:noFill/>
         </p:spPr>
         <p:txBody>
-          <a:bodyPr wrap="square" lIns="0" rIns="0" tIns="0" bIns="0" anchor="t">
+          <a:bodyPr wrap="square" lIns="0" tIns="0" rIns="0" bIns="0" anchor="t">
             <a:spAutoFit/>
           </a:bodyPr>
           <a:lstStyle/>
@@ -11591,7 +11713,7 @@
               </a:spcAft>
             </a:pPr>
             <a:r>
-              <a:rPr sz="1100" b="0">
+              <a:rPr sz="1600" b="0" dirty="0" err="1">
                 <a:solidFill>
                   <a:srgbClr val="62718A"/>
                 </a:solidFill>
@@ -11599,6 +11721,12 @@
               </a:rPr>
               <a:t>abandono</a:t>
             </a:r>
+            <a:endParaRPr sz="1100" b="0" dirty="0">
+              <a:solidFill>
+                <a:srgbClr val="62718A"/>
+              </a:solidFill>
+              <a:latin typeface="Aptos"/>
+            </a:endParaRPr>
           </a:p>
         </p:txBody>
       </p:sp>
@@ -11619,7 +11747,7 @@
           <a:noFill/>
         </p:spPr>
         <p:txBody>
-          <a:bodyPr wrap="square" lIns="0" rIns="0" tIns="0" bIns="0" anchor="t">
+          <a:bodyPr wrap="square" lIns="0" tIns="0" rIns="0" bIns="0" anchor="t">
             <a:spAutoFit/>
           </a:bodyPr>
           <a:lstStyle/>
@@ -11656,7 +11784,7 @@
 </file>
 
 <file path=ppt/slides/slide5.xml><?xml version="1.0" encoding="utf-8"?>
-<p:sld xmlns:a="http://schemas.openxmlformats.org/drawingml/2006/main" xmlns:p="http://schemas.openxmlformats.org/presentationml/2006/main" xmlns:r="http://schemas.openxmlformats.org/officeDocument/2006/relationships">
+<p:sld xmlns:a="http://schemas.openxmlformats.org/drawingml/2006/main" xmlns:r="http://schemas.openxmlformats.org/officeDocument/2006/relationships" xmlns:p="http://schemas.openxmlformats.org/presentationml/2006/main">
   <p:cSld>
     <p:bg>
       <p:bgPr>
@@ -11672,7 +11800,14 @@
         <p:cNvGrpSpPr/>
         <p:nvPr/>
       </p:nvGrpSpPr>
-      <p:grpSpPr/>
+      <p:grpSpPr>
+        <a:xfrm>
+          <a:off x="0" y="0"/>
+          <a:ext cx="0" cy="0"/>
+          <a:chOff x="0" y="0"/>
+          <a:chExt cx="0" cy="0"/>
+        </a:xfrm>
+      </p:grpSpPr>
       <p:cxnSp>
         <p:nvCxnSpPr>
           <p:cNvPr id="2" name="Connector 1"/>
@@ -11783,6 +11918,7 @@
           <a:lstStyle/>
           <a:p>
             <a:pPr algn="ctr"/>
+            <a:endParaRPr/>
           </a:p>
         </p:txBody>
       </p:sp>
@@ -11826,6 +11962,7 @@
           <a:lstStyle/>
           <a:p>
             <a:pPr algn="ctr"/>
+            <a:endParaRPr/>
           </a:p>
         </p:txBody>
       </p:sp>
@@ -11869,6 +12006,7 @@
           <a:lstStyle/>
           <a:p>
             <a:pPr algn="ctr"/>
+            <a:endParaRPr/>
           </a:p>
         </p:txBody>
       </p:sp>
@@ -11889,7 +12027,7 @@
           <a:noFill/>
         </p:spPr>
         <p:txBody>
-          <a:bodyPr wrap="square" lIns="0" rIns="0" tIns="0" bIns="0" anchor="t">
+          <a:bodyPr wrap="square" lIns="0" tIns="0" rIns="0" bIns="0" anchor="t">
             <a:spAutoFit/>
           </a:bodyPr>
           <a:lstStyle/>
@@ -11934,7 +12072,7 @@
           <a:noFill/>
         </p:spPr>
         <p:txBody>
-          <a:bodyPr wrap="square" lIns="0" rIns="0" tIns="0" bIns="0" anchor="t">
+          <a:bodyPr wrap="square" lIns="0" tIns="0" rIns="0" bIns="0" anchor="t">
             <a:spAutoFit/>
           </a:bodyPr>
           <a:lstStyle/>
@@ -12014,7 +12152,7 @@
           <a:noFill/>
         </p:spPr>
         <p:txBody>
-          <a:bodyPr wrap="square" lIns="0" rIns="0" tIns="0" bIns="0" anchor="t">
+          <a:bodyPr wrap="square" lIns="0" tIns="0" rIns="0" bIns="0" anchor="t">
             <a:spAutoFit/>
           </a:bodyPr>
           <a:lstStyle/>
@@ -12059,7 +12197,7 @@
           <a:noFill/>
         </p:spPr>
         <p:txBody>
-          <a:bodyPr wrap="square" lIns="0" rIns="0" tIns="0" bIns="0" anchor="t">
+          <a:bodyPr wrap="square" lIns="0" tIns="0" rIns="0" bIns="0" anchor="t">
             <a:spAutoFit/>
           </a:bodyPr>
           <a:lstStyle/>
@@ -12104,7 +12242,7 @@
           <a:noFill/>
         </p:spPr>
         <p:txBody>
-          <a:bodyPr wrap="square" lIns="0" rIns="0" tIns="0" bIns="0" anchor="t">
+          <a:bodyPr wrap="square" lIns="0" tIns="0" rIns="0" bIns="0" anchor="t">
             <a:spAutoFit/>
           </a:bodyPr>
           <a:lstStyle/>
@@ -12172,6 +12310,7 @@
           <a:lstStyle/>
           <a:p>
             <a:pPr algn="ctr"/>
+            <a:endParaRPr/>
           </a:p>
         </p:txBody>
       </p:sp>
@@ -12215,6 +12354,7 @@
           <a:lstStyle/>
           <a:p>
             <a:pPr algn="ctr"/>
+            <a:endParaRPr/>
           </a:p>
         </p:txBody>
       </p:sp>
@@ -12258,6 +12398,7 @@
           <a:lstStyle/>
           <a:p>
             <a:pPr algn="ctr"/>
+            <a:endParaRPr/>
           </a:p>
         </p:txBody>
       </p:sp>
@@ -12301,6 +12442,7 @@
           <a:lstStyle/>
           <a:p>
             <a:pPr algn="ctr"/>
+            <a:endParaRPr/>
           </a:p>
         </p:txBody>
       </p:sp>
@@ -12344,6 +12486,7 @@
           <a:lstStyle/>
           <a:p>
             <a:pPr algn="ctr"/>
+            <a:endParaRPr/>
           </a:p>
         </p:txBody>
       </p:sp>
@@ -12387,6 +12530,7 @@
           <a:lstStyle/>
           <a:p>
             <a:pPr algn="ctr"/>
+            <a:endParaRPr/>
           </a:p>
         </p:txBody>
       </p:sp>
@@ -12430,6 +12574,7 @@
           <a:lstStyle/>
           <a:p>
             <a:pPr algn="ctr"/>
+            <a:endParaRPr/>
           </a:p>
         </p:txBody>
       </p:sp>
@@ -12473,6 +12618,7 @@
           <a:lstStyle/>
           <a:p>
             <a:pPr algn="ctr"/>
+            <a:endParaRPr/>
           </a:p>
         </p:txBody>
       </p:sp>
@@ -12516,6 +12662,7 @@
           <a:lstStyle/>
           <a:p>
             <a:pPr algn="ctr"/>
+            <a:endParaRPr/>
           </a:p>
         </p:txBody>
       </p:sp>
@@ -12559,6 +12706,7 @@
           <a:lstStyle/>
           <a:p>
             <a:pPr algn="ctr"/>
+            <a:endParaRPr/>
           </a:p>
         </p:txBody>
       </p:sp>
@@ -12602,6 +12750,7 @@
           <a:lstStyle/>
           <a:p>
             <a:pPr algn="ctr"/>
+            <a:endParaRPr/>
           </a:p>
         </p:txBody>
       </p:sp>
@@ -12622,7 +12771,7 @@
           <a:noFill/>
         </p:spPr>
         <p:txBody>
-          <a:bodyPr wrap="square" lIns="0" rIns="0" tIns="0" bIns="0" anchor="t">
+          <a:bodyPr wrap="square" lIns="0" tIns="0" rIns="0" bIns="0" anchor="t">
             <a:spAutoFit/>
           </a:bodyPr>
           <a:lstStyle/>
@@ -12667,7 +12816,7 @@
           <a:noFill/>
         </p:spPr>
         <p:txBody>
-          <a:bodyPr wrap="square" lIns="0" rIns="0" tIns="0" bIns="0" anchor="t">
+          <a:bodyPr wrap="square" lIns="0" tIns="0" rIns="0" bIns="0" anchor="t">
             <a:spAutoFit/>
           </a:bodyPr>
           <a:lstStyle/>
@@ -12739,6 +12888,7 @@
           <a:lstStyle/>
           <a:p>
             <a:pPr algn="ctr"/>
+            <a:endParaRPr/>
           </a:p>
         </p:txBody>
       </p:sp>
@@ -12759,7 +12909,7 @@
           <a:noFill/>
         </p:spPr>
         <p:txBody>
-          <a:bodyPr wrap="square" lIns="0" rIns="0" tIns="0" bIns="0" anchor="t">
+          <a:bodyPr wrap="square" lIns="0" tIns="0" rIns="0" bIns="0" anchor="t">
             <a:spAutoFit/>
           </a:bodyPr>
           <a:lstStyle/>
@@ -12804,7 +12954,7 @@
           <a:noFill/>
         </p:spPr>
         <p:txBody>
-          <a:bodyPr wrap="square" lIns="0" rIns="0" tIns="0" bIns="0" anchor="t">
+          <a:bodyPr wrap="square" lIns="0" tIns="0" rIns="0" bIns="0" anchor="t">
             <a:spAutoFit/>
           </a:bodyPr>
           <a:lstStyle/>
@@ -12849,7 +12999,7 @@
           <a:noFill/>
         </p:spPr>
         <p:txBody>
-          <a:bodyPr wrap="square" lIns="0" rIns="0" tIns="0" bIns="0" anchor="t">
+          <a:bodyPr wrap="square" lIns="0" tIns="0" rIns="0" bIns="0" anchor="t">
             <a:spAutoFit/>
           </a:bodyPr>
           <a:lstStyle/>
@@ -12943,6 +13093,7 @@
           <a:lstStyle/>
           <a:p>
             <a:pPr algn="ctr"/>
+            <a:endParaRPr/>
           </a:p>
         </p:txBody>
       </p:sp>
@@ -12963,7 +13114,7 @@
           <a:noFill/>
         </p:spPr>
         <p:txBody>
-          <a:bodyPr wrap="square" lIns="0" rIns="0" tIns="0" bIns="0" anchor="t">
+          <a:bodyPr wrap="square" lIns="0" tIns="0" rIns="0" bIns="0" anchor="t">
             <a:spAutoFit/>
           </a:bodyPr>
           <a:lstStyle/>
@@ -13008,7 +13159,7 @@
           <a:noFill/>
         </p:spPr>
         <p:txBody>
-          <a:bodyPr wrap="square" lIns="0" rIns="0" tIns="0" bIns="0" anchor="t">
+          <a:bodyPr wrap="square" lIns="0" tIns="0" rIns="0" bIns="0" anchor="t">
             <a:spAutoFit/>
           </a:bodyPr>
           <a:lstStyle/>
@@ -13053,7 +13204,7 @@
           <a:noFill/>
         </p:spPr>
         <p:txBody>
-          <a:bodyPr wrap="square" lIns="0" rIns="0" tIns="0" bIns="0" anchor="t">
+          <a:bodyPr wrap="square" lIns="0" tIns="0" rIns="0" bIns="0" anchor="t">
             <a:spAutoFit/>
           </a:bodyPr>
           <a:lstStyle/>
@@ -13147,6 +13298,7 @@
           <a:lstStyle/>
           <a:p>
             <a:pPr algn="ctr"/>
+            <a:endParaRPr/>
           </a:p>
         </p:txBody>
       </p:sp>
@@ -13167,7 +13319,7 @@
           <a:noFill/>
         </p:spPr>
         <p:txBody>
-          <a:bodyPr wrap="square" lIns="0" rIns="0" tIns="0" bIns="0" anchor="t">
+          <a:bodyPr wrap="square" lIns="0" tIns="0" rIns="0" bIns="0" anchor="t">
             <a:spAutoFit/>
           </a:bodyPr>
           <a:lstStyle/>
@@ -13212,7 +13364,7 @@
           <a:noFill/>
         </p:spPr>
         <p:txBody>
-          <a:bodyPr wrap="square" lIns="0" rIns="0" tIns="0" bIns="0" anchor="t">
+          <a:bodyPr wrap="square" lIns="0" tIns="0" rIns="0" bIns="0" anchor="t">
             <a:spAutoFit/>
           </a:bodyPr>
           <a:lstStyle/>
@@ -13257,7 +13409,7 @@
           <a:noFill/>
         </p:spPr>
         <p:txBody>
-          <a:bodyPr wrap="square" lIns="0" rIns="0" tIns="0" bIns="0" anchor="t">
+          <a:bodyPr wrap="square" lIns="0" tIns="0" rIns="0" bIns="0" anchor="t">
             <a:spAutoFit/>
           </a:bodyPr>
           <a:lstStyle/>
@@ -13324,7 +13476,7 @@
           <a:noFill/>
         </p:spPr>
         <p:txBody>
-          <a:bodyPr wrap="square" lIns="0" rIns="0" tIns="0" bIns="0" anchor="t">
+          <a:bodyPr wrap="square" lIns="0" tIns="0" rIns="0" bIns="0" anchor="t">
             <a:spAutoFit/>
           </a:bodyPr>
           <a:lstStyle/>
@@ -13392,6 +13544,7 @@
           <a:lstStyle/>
           <a:p>
             <a:pPr algn="ctr"/>
+            <a:endParaRPr/>
           </a:p>
         </p:txBody>
       </p:sp>
@@ -13447,7 +13600,7 @@
           <a:noFill/>
         </p:spPr>
         <p:txBody>
-          <a:bodyPr wrap="square" lIns="0" rIns="0" tIns="0" bIns="0" anchor="t">
+          <a:bodyPr wrap="square" lIns="0" tIns="0" rIns="0" bIns="0" anchor="t">
             <a:spAutoFit/>
           </a:bodyPr>
           <a:lstStyle/>
@@ -13515,6 +13668,7 @@
           <a:lstStyle/>
           <a:p>
             <a:pPr algn="ctr"/>
+            <a:endParaRPr/>
           </a:p>
         </p:txBody>
       </p:sp>
@@ -13570,7 +13724,7 @@
           <a:noFill/>
         </p:spPr>
         <p:txBody>
-          <a:bodyPr wrap="square" lIns="0" rIns="0" tIns="0" bIns="0" anchor="t">
+          <a:bodyPr wrap="square" lIns="0" tIns="0" rIns="0" bIns="0" anchor="t">
             <a:spAutoFit/>
           </a:bodyPr>
           <a:lstStyle/>
@@ -13638,6 +13792,7 @@
           <a:lstStyle/>
           <a:p>
             <a:pPr algn="ctr"/>
+            <a:endParaRPr/>
           </a:p>
         </p:txBody>
       </p:sp>
@@ -13693,7 +13848,7 @@
           <a:noFill/>
         </p:spPr>
         <p:txBody>
-          <a:bodyPr wrap="square" lIns="0" rIns="0" tIns="0" bIns="0" anchor="t">
+          <a:bodyPr wrap="square" lIns="0" tIns="0" rIns="0" bIns="0" anchor="t">
             <a:spAutoFit/>
           </a:bodyPr>
           <a:lstStyle/>
@@ -13761,6 +13916,7 @@
           <a:lstStyle/>
           <a:p>
             <a:pPr algn="ctr"/>
+            <a:endParaRPr/>
           </a:p>
         </p:txBody>
       </p:sp>
@@ -13816,7 +13972,7 @@
           <a:noFill/>
         </p:spPr>
         <p:txBody>
-          <a:bodyPr wrap="square" lIns="0" rIns="0" tIns="0" bIns="0" anchor="t">
+          <a:bodyPr wrap="square" lIns="0" tIns="0" rIns="0" bIns="0" anchor="t">
             <a:spAutoFit/>
           </a:bodyPr>
           <a:lstStyle/>
@@ -13884,6 +14040,7 @@
           <a:lstStyle/>
           <a:p>
             <a:pPr algn="ctr"/>
+            <a:endParaRPr/>
           </a:p>
         </p:txBody>
       </p:sp>
@@ -13939,7 +14096,7 @@
           <a:noFill/>
         </p:spPr>
         <p:txBody>
-          <a:bodyPr wrap="square" lIns="0" rIns="0" tIns="0" bIns="0" anchor="t">
+          <a:bodyPr wrap="square" lIns="0" tIns="0" rIns="0" bIns="0" anchor="t">
             <a:spAutoFit/>
           </a:bodyPr>
           <a:lstStyle/>
@@ -14007,6 +14164,7 @@
           <a:lstStyle/>
           <a:p>
             <a:pPr algn="ctr"/>
+            <a:endParaRPr/>
           </a:p>
         </p:txBody>
       </p:sp>
@@ -14027,7 +14185,7 @@
           <a:noFill/>
         </p:spPr>
         <p:txBody>
-          <a:bodyPr wrap="square" lIns="0" rIns="0" tIns="0" bIns="0" anchor="t">
+          <a:bodyPr wrap="square" lIns="0" tIns="0" rIns="0" bIns="0" anchor="t">
             <a:spAutoFit/>
           </a:bodyPr>
           <a:lstStyle/>
@@ -14072,7 +14230,7 @@
           <a:noFill/>
         </p:spPr>
         <p:txBody>
-          <a:bodyPr wrap="square" lIns="0" rIns="0" tIns="0" bIns="0" anchor="t">
+          <a:bodyPr wrap="square" lIns="0" tIns="0" rIns="0" bIns="0" anchor="t">
             <a:spAutoFit/>
           </a:bodyPr>
           <a:lstStyle/>
@@ -14109,7 +14267,7 @@
 </file>
 
 <file path=ppt/slides/slide6.xml><?xml version="1.0" encoding="utf-8"?>
-<p:sld xmlns:a="http://schemas.openxmlformats.org/drawingml/2006/main" xmlns:p="http://schemas.openxmlformats.org/presentationml/2006/main" xmlns:r="http://schemas.openxmlformats.org/officeDocument/2006/relationships">
+<p:sld xmlns:a="http://schemas.openxmlformats.org/drawingml/2006/main" xmlns:r="http://schemas.openxmlformats.org/officeDocument/2006/relationships" xmlns:p="http://schemas.openxmlformats.org/presentationml/2006/main">
   <p:cSld>
     <p:bg>
       <p:bgPr>
@@ -14125,7 +14283,14 @@
         <p:cNvGrpSpPr/>
         <p:nvPr/>
       </p:nvGrpSpPr>
-      <p:grpSpPr/>
+      <p:grpSpPr>
+        <a:xfrm>
+          <a:off x="0" y="0"/>
+          <a:ext cx="0" cy="0"/>
+          <a:chOff x="0" y="0"/>
+          <a:chExt cx="0" cy="0"/>
+        </a:xfrm>
+      </p:grpSpPr>
       <p:cxnSp>
         <p:nvCxnSpPr>
           <p:cNvPr id="2" name="Connector 1"/>
@@ -14236,6 +14401,7 @@
           <a:lstStyle/>
           <a:p>
             <a:pPr algn="ctr"/>
+            <a:endParaRPr/>
           </a:p>
         </p:txBody>
       </p:sp>
@@ -14279,6 +14445,7 @@
           <a:lstStyle/>
           <a:p>
             <a:pPr algn="ctr"/>
+            <a:endParaRPr/>
           </a:p>
         </p:txBody>
       </p:sp>
@@ -14322,6 +14489,7 @@
           <a:lstStyle/>
           <a:p>
             <a:pPr algn="ctr"/>
+            <a:endParaRPr/>
           </a:p>
         </p:txBody>
       </p:sp>
@@ -14342,7 +14510,7 @@
           <a:noFill/>
         </p:spPr>
         <p:txBody>
-          <a:bodyPr wrap="square" lIns="0" rIns="0" tIns="0" bIns="0" anchor="t">
+          <a:bodyPr wrap="square" lIns="0" tIns="0" rIns="0" bIns="0" anchor="t">
             <a:spAutoFit/>
           </a:bodyPr>
           <a:lstStyle/>
@@ -14387,7 +14555,7 @@
           <a:noFill/>
         </p:spPr>
         <p:txBody>
-          <a:bodyPr wrap="square" lIns="0" rIns="0" tIns="0" bIns="0" anchor="t">
+          <a:bodyPr wrap="square" lIns="0" tIns="0" rIns="0" bIns="0" anchor="t">
             <a:spAutoFit/>
           </a:bodyPr>
           <a:lstStyle/>
@@ -14467,7 +14635,7 @@
           <a:noFill/>
         </p:spPr>
         <p:txBody>
-          <a:bodyPr wrap="square" lIns="0" rIns="0" tIns="0" bIns="0" anchor="t">
+          <a:bodyPr wrap="square" lIns="0" tIns="0" rIns="0" bIns="0" anchor="t">
             <a:spAutoFit/>
           </a:bodyPr>
           <a:lstStyle/>
@@ -14512,7 +14680,7 @@
           <a:noFill/>
         </p:spPr>
         <p:txBody>
-          <a:bodyPr wrap="square" lIns="0" rIns="0" tIns="0" bIns="0" anchor="t">
+          <a:bodyPr wrap="square" lIns="0" tIns="0" rIns="0" bIns="0" anchor="t">
             <a:spAutoFit/>
           </a:bodyPr>
           <a:lstStyle/>
@@ -14557,7 +14725,7 @@
           <a:noFill/>
         </p:spPr>
         <p:txBody>
-          <a:bodyPr wrap="square" lIns="0" rIns="0" tIns="0" bIns="0" anchor="t">
+          <a:bodyPr wrap="square" lIns="0" tIns="0" rIns="0" bIns="0" anchor="t">
             <a:spAutoFit/>
           </a:bodyPr>
           <a:lstStyle/>
@@ -14625,6 +14793,7 @@
           <a:lstStyle/>
           <a:p>
             <a:pPr algn="ctr"/>
+            <a:endParaRPr/>
           </a:p>
         </p:txBody>
       </p:sp>
@@ -14668,6 +14837,7 @@
           <a:lstStyle/>
           <a:p>
             <a:pPr algn="ctr"/>
+            <a:endParaRPr/>
           </a:p>
         </p:txBody>
       </p:sp>
@@ -14711,6 +14881,7 @@
           <a:lstStyle/>
           <a:p>
             <a:pPr algn="ctr"/>
+            <a:endParaRPr/>
           </a:p>
         </p:txBody>
       </p:sp>
@@ -14754,6 +14925,7 @@
           <a:lstStyle/>
           <a:p>
             <a:pPr algn="ctr"/>
+            <a:endParaRPr/>
           </a:p>
         </p:txBody>
       </p:sp>
@@ -14797,6 +14969,7 @@
           <a:lstStyle/>
           <a:p>
             <a:pPr algn="ctr"/>
+            <a:endParaRPr/>
           </a:p>
         </p:txBody>
       </p:sp>
@@ -14840,6 +15013,7 @@
           <a:lstStyle/>
           <a:p>
             <a:pPr algn="ctr"/>
+            <a:endParaRPr/>
           </a:p>
         </p:txBody>
       </p:sp>
@@ -14883,6 +15057,7 @@
           <a:lstStyle/>
           <a:p>
             <a:pPr algn="ctr"/>
+            <a:endParaRPr/>
           </a:p>
         </p:txBody>
       </p:sp>
@@ -14926,6 +15101,7 @@
           <a:lstStyle/>
           <a:p>
             <a:pPr algn="ctr"/>
+            <a:endParaRPr/>
           </a:p>
         </p:txBody>
       </p:sp>
@@ -14969,6 +15145,7 @@
           <a:lstStyle/>
           <a:p>
             <a:pPr algn="ctr"/>
+            <a:endParaRPr/>
           </a:p>
         </p:txBody>
       </p:sp>
@@ -15012,6 +15189,7 @@
           <a:lstStyle/>
           <a:p>
             <a:pPr algn="ctr"/>
+            <a:endParaRPr/>
           </a:p>
         </p:txBody>
       </p:sp>
@@ -15055,6 +15233,7 @@
           <a:lstStyle/>
           <a:p>
             <a:pPr algn="ctr"/>
+            <a:endParaRPr/>
           </a:p>
         </p:txBody>
       </p:sp>
@@ -15075,7 +15254,7 @@
           <a:noFill/>
         </p:spPr>
         <p:txBody>
-          <a:bodyPr wrap="square" lIns="0" rIns="0" tIns="0" bIns="0" anchor="t">
+          <a:bodyPr wrap="square" lIns="0" tIns="0" rIns="0" bIns="0" anchor="t">
             <a:spAutoFit/>
           </a:bodyPr>
           <a:lstStyle/>
@@ -15120,7 +15299,7 @@
           <a:noFill/>
         </p:spPr>
         <p:txBody>
-          <a:bodyPr wrap="square" lIns="0" rIns="0" tIns="0" bIns="0" anchor="t">
+          <a:bodyPr wrap="square" lIns="0" tIns="0" rIns="0" bIns="0" anchor="t">
             <a:spAutoFit/>
           </a:bodyPr>
           <a:lstStyle/>
@@ -15192,6 +15371,7 @@
           <a:lstStyle/>
           <a:p>
             <a:pPr algn="ctr"/>
+            <a:endParaRPr/>
           </a:p>
         </p:txBody>
       </p:sp>
@@ -15239,6 +15419,7 @@
           <a:lstStyle/>
           <a:p>
             <a:pPr algn="ctr"/>
+            <a:endParaRPr/>
           </a:p>
         </p:txBody>
       </p:sp>
@@ -15282,6 +15463,7 @@
           <a:lstStyle/>
           <a:p>
             <a:pPr algn="ctr"/>
+            <a:endParaRPr/>
           </a:p>
         </p:txBody>
       </p:sp>
@@ -15325,6 +15507,7 @@
           <a:lstStyle/>
           <a:p>
             <a:pPr algn="ctr"/>
+            <a:endParaRPr/>
           </a:p>
         </p:txBody>
       </p:sp>
@@ -15345,7 +15528,7 @@
           <a:noFill/>
         </p:spPr>
         <p:txBody>
-          <a:bodyPr wrap="square" lIns="0" rIns="0" tIns="0" bIns="0" anchor="t">
+          <a:bodyPr wrap="square" lIns="0" tIns="0" rIns="0" bIns="0" anchor="t">
             <a:spAutoFit/>
           </a:bodyPr>
           <a:lstStyle/>
@@ -15390,7 +15573,7 @@
           <a:noFill/>
         </p:spPr>
         <p:txBody>
-          <a:bodyPr wrap="square" lIns="0" rIns="0" tIns="0" bIns="0" anchor="t">
+          <a:bodyPr wrap="square" lIns="0" tIns="0" rIns="0" bIns="0" anchor="t">
             <a:spAutoFit/>
           </a:bodyPr>
           <a:lstStyle/>
@@ -15435,7 +15618,7 @@
           <a:noFill/>
         </p:spPr>
         <p:txBody>
-          <a:bodyPr wrap="square" lIns="0" rIns="0" tIns="0" bIns="0" anchor="t">
+          <a:bodyPr wrap="square" lIns="0" tIns="0" rIns="0" bIns="0" anchor="t">
             <a:spAutoFit/>
           </a:bodyPr>
           <a:lstStyle/>
@@ -15970,7 +16153,7 @@
           <a:noFill/>
         </p:spPr>
         <p:txBody>
-          <a:bodyPr wrap="square" lIns="0" rIns="0" tIns="0" bIns="0" anchor="t">
+          <a:bodyPr wrap="square" lIns="0" tIns="0" rIns="0" bIns="0" anchor="t">
             <a:spAutoFit/>
           </a:bodyPr>
           <a:lstStyle/>
@@ -16015,7 +16198,7 @@
           <a:noFill/>
         </p:spPr>
         <p:txBody>
-          <a:bodyPr wrap="square" lIns="0" rIns="0" tIns="0" bIns="0" anchor="t">
+          <a:bodyPr wrap="square" lIns="0" tIns="0" rIns="0" bIns="0" anchor="t">
             <a:spAutoFit/>
           </a:bodyPr>
           <a:lstStyle/>
@@ -16060,7 +16243,7 @@
           <a:noFill/>
         </p:spPr>
         <p:txBody>
-          <a:bodyPr wrap="square" lIns="0" rIns="0" tIns="0" bIns="0" anchor="t">
+          <a:bodyPr wrap="square" lIns="0" tIns="0" rIns="0" bIns="0" anchor="t">
             <a:spAutoFit/>
           </a:bodyPr>
           <a:lstStyle/>
@@ -16130,6 +16313,7 @@
           <a:lstStyle/>
           <a:p>
             <a:pPr algn="ctr"/>
+            <a:endParaRPr/>
           </a:p>
         </p:txBody>
       </p:sp>
@@ -16150,7 +16334,7 @@
           <a:noFill/>
         </p:spPr>
         <p:txBody>
-          <a:bodyPr wrap="square" lIns="0" rIns="0" tIns="0" bIns="0" anchor="t">
+          <a:bodyPr wrap="square" lIns="0" tIns="0" rIns="0" bIns="0" anchor="t">
             <a:spAutoFit/>
           </a:bodyPr>
           <a:lstStyle/>
@@ -16187,7 +16371,7 @@
 </file>
 
 <file path=ppt/slides/slide7.xml><?xml version="1.0" encoding="utf-8"?>
-<p:sld xmlns:a="http://schemas.openxmlformats.org/drawingml/2006/main" xmlns:p="http://schemas.openxmlformats.org/presentationml/2006/main" xmlns:r="http://schemas.openxmlformats.org/officeDocument/2006/relationships">
+<p:sld xmlns:a="http://schemas.openxmlformats.org/drawingml/2006/main" xmlns:r="http://schemas.openxmlformats.org/officeDocument/2006/relationships" xmlns:p="http://schemas.openxmlformats.org/presentationml/2006/main">
   <p:cSld>
     <p:bg>
       <p:bgPr>
@@ -16203,7 +16387,14 @@
         <p:cNvGrpSpPr/>
         <p:nvPr/>
       </p:nvGrpSpPr>
-      <p:grpSpPr/>
+      <p:grpSpPr>
+        <a:xfrm>
+          <a:off x="0" y="0"/>
+          <a:ext cx="0" cy="0"/>
+          <a:chOff x="0" y="0"/>
+          <a:chExt cx="0" cy="0"/>
+        </a:xfrm>
+      </p:grpSpPr>
       <p:cxnSp>
         <p:nvCxnSpPr>
           <p:cNvPr id="2" name="Connector 1"/>
@@ -16314,6 +16505,7 @@
           <a:lstStyle/>
           <a:p>
             <a:pPr algn="ctr"/>
+            <a:endParaRPr/>
           </a:p>
         </p:txBody>
       </p:sp>
@@ -16357,6 +16549,7 @@
           <a:lstStyle/>
           <a:p>
             <a:pPr algn="ctr"/>
+            <a:endParaRPr/>
           </a:p>
         </p:txBody>
       </p:sp>
@@ -16400,6 +16593,7 @@
           <a:lstStyle/>
           <a:p>
             <a:pPr algn="ctr"/>
+            <a:endParaRPr/>
           </a:p>
         </p:txBody>
       </p:sp>
@@ -16420,7 +16614,7 @@
           <a:noFill/>
         </p:spPr>
         <p:txBody>
-          <a:bodyPr wrap="square" lIns="0" rIns="0" tIns="0" bIns="0" anchor="t">
+          <a:bodyPr wrap="square" lIns="0" tIns="0" rIns="0" bIns="0" anchor="t">
             <a:spAutoFit/>
           </a:bodyPr>
           <a:lstStyle/>
@@ -16465,7 +16659,7 @@
           <a:noFill/>
         </p:spPr>
         <p:txBody>
-          <a:bodyPr wrap="square" lIns="0" rIns="0" tIns="0" bIns="0" anchor="t">
+          <a:bodyPr wrap="square" lIns="0" tIns="0" rIns="0" bIns="0" anchor="t">
             <a:spAutoFit/>
           </a:bodyPr>
           <a:lstStyle/>
@@ -16545,7 +16739,7 @@
           <a:noFill/>
         </p:spPr>
         <p:txBody>
-          <a:bodyPr wrap="square" lIns="0" rIns="0" tIns="0" bIns="0" anchor="t">
+          <a:bodyPr wrap="square" lIns="0" tIns="0" rIns="0" bIns="0" anchor="t">
             <a:spAutoFit/>
           </a:bodyPr>
           <a:lstStyle/>
@@ -16590,7 +16784,7 @@
           <a:noFill/>
         </p:spPr>
         <p:txBody>
-          <a:bodyPr wrap="square" lIns="0" rIns="0" tIns="0" bIns="0" anchor="t">
+          <a:bodyPr wrap="square" lIns="0" tIns="0" rIns="0" bIns="0" anchor="t">
             <a:spAutoFit/>
           </a:bodyPr>
           <a:lstStyle/>
@@ -16635,7 +16829,7 @@
           <a:noFill/>
         </p:spPr>
         <p:txBody>
-          <a:bodyPr wrap="square" lIns="0" rIns="0" tIns="0" bIns="0" anchor="t">
+          <a:bodyPr wrap="square" lIns="0" tIns="0" rIns="0" bIns="0" anchor="t">
             <a:spAutoFit/>
           </a:bodyPr>
           <a:lstStyle/>
@@ -16703,6 +16897,7 @@
           <a:lstStyle/>
           <a:p>
             <a:pPr algn="ctr"/>
+            <a:endParaRPr/>
           </a:p>
         </p:txBody>
       </p:sp>
@@ -16746,6 +16941,7 @@
           <a:lstStyle/>
           <a:p>
             <a:pPr algn="ctr"/>
+            <a:endParaRPr/>
           </a:p>
         </p:txBody>
       </p:sp>
@@ -16789,6 +16985,7 @@
           <a:lstStyle/>
           <a:p>
             <a:pPr algn="ctr"/>
+            <a:endParaRPr/>
           </a:p>
         </p:txBody>
       </p:sp>
@@ -16832,6 +17029,7 @@
           <a:lstStyle/>
           <a:p>
             <a:pPr algn="ctr"/>
+            <a:endParaRPr/>
           </a:p>
         </p:txBody>
       </p:sp>
@@ -16875,6 +17073,7 @@
           <a:lstStyle/>
           <a:p>
             <a:pPr algn="ctr"/>
+            <a:endParaRPr/>
           </a:p>
         </p:txBody>
       </p:sp>
@@ -16918,6 +17117,7 @@
           <a:lstStyle/>
           <a:p>
             <a:pPr algn="ctr"/>
+            <a:endParaRPr/>
           </a:p>
         </p:txBody>
       </p:sp>
@@ -16961,6 +17161,7 @@
           <a:lstStyle/>
           <a:p>
             <a:pPr algn="ctr"/>
+            <a:endParaRPr/>
           </a:p>
         </p:txBody>
       </p:sp>
@@ -17004,6 +17205,7 @@
           <a:lstStyle/>
           <a:p>
             <a:pPr algn="ctr"/>
+            <a:endParaRPr/>
           </a:p>
         </p:txBody>
       </p:sp>
@@ -17047,6 +17249,7 @@
           <a:lstStyle/>
           <a:p>
             <a:pPr algn="ctr"/>
+            <a:endParaRPr/>
           </a:p>
         </p:txBody>
       </p:sp>
@@ -17090,6 +17293,7 @@
           <a:lstStyle/>
           <a:p>
             <a:pPr algn="ctr"/>
+            <a:endParaRPr/>
           </a:p>
         </p:txBody>
       </p:sp>
@@ -17133,6 +17337,7 @@
           <a:lstStyle/>
           <a:p>
             <a:pPr algn="ctr"/>
+            <a:endParaRPr/>
           </a:p>
         </p:txBody>
       </p:sp>
@@ -17153,7 +17358,7 @@
           <a:noFill/>
         </p:spPr>
         <p:txBody>
-          <a:bodyPr wrap="square" lIns="0" rIns="0" tIns="0" bIns="0" anchor="t">
+          <a:bodyPr wrap="square" lIns="0" tIns="0" rIns="0" bIns="0" anchor="t">
             <a:spAutoFit/>
           </a:bodyPr>
           <a:lstStyle/>
@@ -17198,7 +17403,7 @@
           <a:noFill/>
         </p:spPr>
         <p:txBody>
-          <a:bodyPr wrap="square" lIns="0" rIns="0" tIns="0" bIns="0" anchor="t">
+          <a:bodyPr wrap="square" lIns="0" tIns="0" rIns="0" bIns="0" anchor="t">
             <a:spAutoFit/>
           </a:bodyPr>
           <a:lstStyle/>
@@ -17243,7 +17448,7 @@
           <a:noFill/>
         </p:spPr>
         <p:txBody>
-          <a:bodyPr wrap="square" lIns="0" rIns="0" tIns="0" bIns="0" anchor="t">
+          <a:bodyPr wrap="square" lIns="0" tIns="0" rIns="0" bIns="0" anchor="t">
             <a:spAutoFit/>
           </a:bodyPr>
           <a:lstStyle/>
@@ -17313,6 +17518,7 @@
           <a:lstStyle/>
           <a:p>
             <a:pPr algn="ctr"/>
+            <a:endParaRPr/>
           </a:p>
         </p:txBody>
       </p:sp>
@@ -17358,6 +17564,7 @@
           <a:lstStyle/>
           <a:p>
             <a:pPr algn="ctr"/>
+            <a:endParaRPr/>
           </a:p>
         </p:txBody>
       </p:sp>
@@ -17378,7 +17585,7 @@
           <a:noFill/>
         </p:spPr>
         <p:txBody>
-          <a:bodyPr wrap="square" lIns="0" rIns="0" tIns="0" bIns="0" anchor="t">
+          <a:bodyPr wrap="square" lIns="0" tIns="0" rIns="0" bIns="0" anchor="t">
             <a:spAutoFit/>
           </a:bodyPr>
           <a:lstStyle/>
@@ -17423,7 +17630,7 @@
           <a:noFill/>
         </p:spPr>
         <p:txBody>
-          <a:bodyPr wrap="square" lIns="0" rIns="0" tIns="0" bIns="0" anchor="t">
+          <a:bodyPr wrap="square" lIns="0" tIns="0" rIns="0" bIns="0" anchor="t">
             <a:spAutoFit/>
           </a:bodyPr>
           <a:lstStyle/>
@@ -17468,7 +17675,7 @@
           <a:noFill/>
         </p:spPr>
         <p:txBody>
-          <a:bodyPr wrap="square" lIns="0" rIns="0" tIns="0" bIns="0" anchor="t">
+          <a:bodyPr wrap="square" lIns="0" tIns="0" rIns="0" bIns="0" anchor="t">
             <a:spAutoFit/>
           </a:bodyPr>
           <a:lstStyle/>
@@ -17538,6 +17745,7 @@
           <a:lstStyle/>
           <a:p>
             <a:pPr algn="ctr"/>
+            <a:endParaRPr/>
           </a:p>
         </p:txBody>
       </p:sp>
@@ -17583,6 +17791,7 @@
           <a:lstStyle/>
           <a:p>
             <a:pPr algn="ctr"/>
+            <a:endParaRPr/>
           </a:p>
         </p:txBody>
       </p:sp>
@@ -17603,7 +17812,7 @@
           <a:noFill/>
         </p:spPr>
         <p:txBody>
-          <a:bodyPr wrap="square" lIns="0" rIns="0" tIns="0" bIns="0" anchor="t">
+          <a:bodyPr wrap="square" lIns="0" tIns="0" rIns="0" bIns="0" anchor="t">
             <a:spAutoFit/>
           </a:bodyPr>
           <a:lstStyle/>
@@ -17648,7 +17857,7 @@
           <a:noFill/>
         </p:spPr>
         <p:txBody>
-          <a:bodyPr wrap="square" lIns="0" rIns="0" tIns="0" bIns="0" anchor="t">
+          <a:bodyPr wrap="square" lIns="0" tIns="0" rIns="0" bIns="0" anchor="t">
             <a:spAutoFit/>
           </a:bodyPr>
           <a:lstStyle/>
@@ -17693,7 +17902,7 @@
           <a:noFill/>
         </p:spPr>
         <p:txBody>
-          <a:bodyPr wrap="square" lIns="0" rIns="0" tIns="0" bIns="0" anchor="t">
+          <a:bodyPr wrap="square" lIns="0" tIns="0" rIns="0" bIns="0" anchor="t">
             <a:spAutoFit/>
           </a:bodyPr>
           <a:lstStyle/>
@@ -17763,6 +17972,7 @@
           <a:lstStyle/>
           <a:p>
             <a:pPr algn="ctr"/>
+            <a:endParaRPr/>
           </a:p>
         </p:txBody>
       </p:sp>
@@ -17808,6 +18018,7 @@
           <a:lstStyle/>
           <a:p>
             <a:pPr algn="ctr"/>
+            <a:endParaRPr/>
           </a:p>
         </p:txBody>
       </p:sp>
@@ -17828,7 +18039,7 @@
           <a:noFill/>
         </p:spPr>
         <p:txBody>
-          <a:bodyPr wrap="square" lIns="0" rIns="0" tIns="0" bIns="0" anchor="t">
+          <a:bodyPr wrap="square" lIns="0" tIns="0" rIns="0" bIns="0" anchor="t">
             <a:spAutoFit/>
           </a:bodyPr>
           <a:lstStyle/>
@@ -17873,7 +18084,7 @@
           <a:noFill/>
         </p:spPr>
         <p:txBody>
-          <a:bodyPr wrap="square" lIns="0" rIns="0" tIns="0" bIns="0" anchor="t">
+          <a:bodyPr wrap="square" lIns="0" tIns="0" rIns="0" bIns="0" anchor="t">
             <a:spAutoFit/>
           </a:bodyPr>
           <a:lstStyle/>
@@ -17941,6 +18152,7 @@
           <a:lstStyle/>
           <a:p>
             <a:pPr algn="ctr"/>
+            <a:endParaRPr/>
           </a:p>
         </p:txBody>
       </p:sp>
@@ -17961,7 +18173,7 @@
           <a:noFill/>
         </p:spPr>
         <p:txBody>
-          <a:bodyPr wrap="square" lIns="0" rIns="0" tIns="0" bIns="0" anchor="t">
+          <a:bodyPr wrap="square" lIns="0" tIns="0" rIns="0" bIns="0" anchor="t">
             <a:spAutoFit/>
           </a:bodyPr>
           <a:lstStyle/>
@@ -18029,6 +18241,7 @@
           <a:lstStyle/>
           <a:p>
             <a:pPr algn="ctr"/>
+            <a:endParaRPr/>
           </a:p>
         </p:txBody>
       </p:sp>
@@ -18049,7 +18262,7 @@
           <a:noFill/>
         </p:spPr>
         <p:txBody>
-          <a:bodyPr wrap="square" lIns="0" rIns="0" tIns="0" bIns="0" anchor="t">
+          <a:bodyPr wrap="square" lIns="0" tIns="0" rIns="0" bIns="0" anchor="t">
             <a:spAutoFit/>
           </a:bodyPr>
           <a:lstStyle/>
@@ -18129,7 +18342,7 @@
           <a:noFill/>
         </p:spPr>
         <p:txBody>
-          <a:bodyPr wrap="square" lIns="0" rIns="0" tIns="0" bIns="0" anchor="t">
+          <a:bodyPr wrap="square" lIns="0" tIns="0" rIns="0" bIns="0" anchor="t">
             <a:spAutoFit/>
           </a:bodyPr>
           <a:lstStyle/>
@@ -18174,7 +18387,7 @@
           <a:noFill/>
         </p:spPr>
         <p:txBody>
-          <a:bodyPr wrap="square" lIns="0" rIns="0" tIns="0" bIns="0" anchor="t">
+          <a:bodyPr wrap="square" lIns="0" tIns="0" rIns="0" bIns="0" anchor="t">
             <a:spAutoFit/>
           </a:bodyPr>
           <a:lstStyle/>
@@ -18241,7 +18454,7 @@
           <a:noFill/>
         </p:spPr>
         <p:txBody>
-          <a:bodyPr wrap="square" lIns="0" rIns="0" tIns="0" bIns="0" anchor="t">
+          <a:bodyPr wrap="square" lIns="0" tIns="0" rIns="0" bIns="0" anchor="t">
             <a:spAutoFit/>
           </a:bodyPr>
           <a:lstStyle/>
@@ -18258,7 +18471,7 @@
               </a:spcAft>
             </a:pPr>
             <a:r>
-              <a:rPr sz="1500" b="1">
+              <a:rPr sz="1500" b="1" dirty="0">
                 <a:solidFill>
                   <a:srgbClr val="55D6CA"/>
                 </a:solidFill>
@@ -18278,7 +18491,7 @@
 </file>
 
 <file path=ppt/slides/slide8.xml><?xml version="1.0" encoding="utf-8"?>
-<p:sld xmlns:a="http://schemas.openxmlformats.org/drawingml/2006/main" xmlns:p="http://schemas.openxmlformats.org/presentationml/2006/main" xmlns:r="http://schemas.openxmlformats.org/officeDocument/2006/relationships">
+<p:sld xmlns:a="http://schemas.openxmlformats.org/drawingml/2006/main" xmlns:r="http://schemas.openxmlformats.org/officeDocument/2006/relationships" xmlns:p="http://schemas.openxmlformats.org/presentationml/2006/main">
   <p:cSld>
     <p:bg>
       <p:bgPr>
@@ -18294,7 +18507,14 @@
         <p:cNvGrpSpPr/>
         <p:nvPr/>
       </p:nvGrpSpPr>
-      <p:grpSpPr/>
+      <p:grpSpPr>
+        <a:xfrm>
+          <a:off x="0" y="0"/>
+          <a:ext cx="0" cy="0"/>
+          <a:chOff x="0" y="0"/>
+          <a:chExt cx="0" cy="0"/>
+        </a:xfrm>
+      </p:grpSpPr>
       <p:cxnSp>
         <p:nvCxnSpPr>
           <p:cNvPr id="2" name="Connector 1"/>
@@ -18405,6 +18625,7 @@
           <a:lstStyle/>
           <a:p>
             <a:pPr algn="ctr"/>
+            <a:endParaRPr/>
           </a:p>
         </p:txBody>
       </p:sp>
@@ -18448,6 +18669,7 @@
           <a:lstStyle/>
           <a:p>
             <a:pPr algn="ctr"/>
+            <a:endParaRPr/>
           </a:p>
         </p:txBody>
       </p:sp>
@@ -18491,6 +18713,7 @@
           <a:lstStyle/>
           <a:p>
             <a:pPr algn="ctr"/>
+            <a:endParaRPr/>
           </a:p>
         </p:txBody>
       </p:sp>
@@ -18511,7 +18734,7 @@
           <a:noFill/>
         </p:spPr>
         <p:txBody>
-          <a:bodyPr wrap="square" lIns="0" rIns="0" tIns="0" bIns="0" anchor="t">
+          <a:bodyPr wrap="square" lIns="0" tIns="0" rIns="0" bIns="0" anchor="t">
             <a:spAutoFit/>
           </a:bodyPr>
           <a:lstStyle/>
@@ -18556,7 +18779,7 @@
           <a:noFill/>
         </p:spPr>
         <p:txBody>
-          <a:bodyPr wrap="square" lIns="0" rIns="0" tIns="0" bIns="0" anchor="t">
+          <a:bodyPr wrap="square" lIns="0" tIns="0" rIns="0" bIns="0" anchor="t">
             <a:spAutoFit/>
           </a:bodyPr>
           <a:lstStyle/>
@@ -18636,7 +18859,7 @@
           <a:noFill/>
         </p:spPr>
         <p:txBody>
-          <a:bodyPr wrap="square" lIns="0" rIns="0" tIns="0" bIns="0" anchor="t">
+          <a:bodyPr wrap="square" lIns="0" tIns="0" rIns="0" bIns="0" anchor="t">
             <a:spAutoFit/>
           </a:bodyPr>
           <a:lstStyle/>
@@ -18681,7 +18904,7 @@
           <a:noFill/>
         </p:spPr>
         <p:txBody>
-          <a:bodyPr wrap="square" lIns="0" rIns="0" tIns="0" bIns="0" anchor="t">
+          <a:bodyPr wrap="square" lIns="0" tIns="0" rIns="0" bIns="0" anchor="t">
             <a:spAutoFit/>
           </a:bodyPr>
           <a:lstStyle/>
@@ -18726,7 +18949,7 @@
           <a:noFill/>
         </p:spPr>
         <p:txBody>
-          <a:bodyPr wrap="square" lIns="0" rIns="0" tIns="0" bIns="0" anchor="t">
+          <a:bodyPr wrap="square" lIns="0" tIns="0" rIns="0" bIns="0" anchor="t">
             <a:spAutoFit/>
           </a:bodyPr>
           <a:lstStyle/>
@@ -18794,6 +19017,7 @@
           <a:lstStyle/>
           <a:p>
             <a:pPr algn="ctr"/>
+            <a:endParaRPr/>
           </a:p>
         </p:txBody>
       </p:sp>
@@ -18837,6 +19061,7 @@
           <a:lstStyle/>
           <a:p>
             <a:pPr algn="ctr"/>
+            <a:endParaRPr/>
           </a:p>
         </p:txBody>
       </p:sp>
@@ -18880,6 +19105,7 @@
           <a:lstStyle/>
           <a:p>
             <a:pPr algn="ctr"/>
+            <a:endParaRPr/>
           </a:p>
         </p:txBody>
       </p:sp>
@@ -18923,6 +19149,7 @@
           <a:lstStyle/>
           <a:p>
             <a:pPr algn="ctr"/>
+            <a:endParaRPr/>
           </a:p>
         </p:txBody>
       </p:sp>
@@ -18966,6 +19193,7 @@
           <a:lstStyle/>
           <a:p>
             <a:pPr algn="ctr"/>
+            <a:endParaRPr/>
           </a:p>
         </p:txBody>
       </p:sp>
@@ -19009,6 +19237,7 @@
           <a:lstStyle/>
           <a:p>
             <a:pPr algn="ctr"/>
+            <a:endParaRPr/>
           </a:p>
         </p:txBody>
       </p:sp>
@@ -19052,6 +19281,7 @@
           <a:lstStyle/>
           <a:p>
             <a:pPr algn="ctr"/>
+            <a:endParaRPr/>
           </a:p>
         </p:txBody>
       </p:sp>
@@ -19095,6 +19325,7 @@
           <a:lstStyle/>
           <a:p>
             <a:pPr algn="ctr"/>
+            <a:endParaRPr/>
           </a:p>
         </p:txBody>
       </p:sp>
@@ -19138,6 +19369,7 @@
           <a:lstStyle/>
           <a:p>
             <a:pPr algn="ctr"/>
+            <a:endParaRPr/>
           </a:p>
         </p:txBody>
       </p:sp>
@@ -19181,6 +19413,7 @@
           <a:lstStyle/>
           <a:p>
             <a:pPr algn="ctr"/>
+            <a:endParaRPr/>
           </a:p>
         </p:txBody>
       </p:sp>
@@ -19224,6 +19457,7 @@
           <a:lstStyle/>
           <a:p>
             <a:pPr algn="ctr"/>
+            <a:endParaRPr/>
           </a:p>
         </p:txBody>
       </p:sp>
@@ -19244,7 +19478,7 @@
           <a:noFill/>
         </p:spPr>
         <p:txBody>
-          <a:bodyPr wrap="square" lIns="0" rIns="0" tIns="0" bIns="0" anchor="t">
+          <a:bodyPr wrap="square" lIns="0" tIns="0" rIns="0" bIns="0" anchor="t">
             <a:spAutoFit/>
           </a:bodyPr>
           <a:lstStyle/>
@@ -19289,7 +19523,7 @@
           <a:noFill/>
         </p:spPr>
         <p:txBody>
-          <a:bodyPr wrap="square" lIns="0" rIns="0" tIns="0" bIns="0" anchor="t">
+          <a:bodyPr wrap="square" lIns="0" tIns="0" rIns="0" bIns="0" anchor="t">
             <a:spAutoFit/>
           </a:bodyPr>
           <a:lstStyle/>
@@ -19334,7 +19568,7 @@
           <a:noFill/>
         </p:spPr>
         <p:txBody>
-          <a:bodyPr wrap="square" lIns="0" rIns="0" tIns="0" bIns="0" anchor="t">
+          <a:bodyPr wrap="square" lIns="0" tIns="0" rIns="0" bIns="0" anchor="t">
             <a:spAutoFit/>
           </a:bodyPr>
           <a:lstStyle/>
@@ -19379,7 +19613,7 @@
           <a:noFill/>
         </p:spPr>
         <p:txBody>
-          <a:bodyPr wrap="square" lIns="0" rIns="0" tIns="0" bIns="0" anchor="t">
+          <a:bodyPr wrap="square" lIns="0" tIns="0" rIns="0" bIns="0" anchor="t">
             <a:spAutoFit/>
           </a:bodyPr>
           <a:lstStyle/>
@@ -19449,6 +19683,7 @@
           <a:lstStyle/>
           <a:p>
             <a:pPr algn="ctr"/>
+            <a:endParaRPr/>
           </a:p>
         </p:txBody>
       </p:sp>
@@ -19494,6 +19729,7 @@
           <a:lstStyle/>
           <a:p>
             <a:pPr algn="ctr"/>
+            <a:endParaRPr/>
           </a:p>
         </p:txBody>
       </p:sp>
@@ -19514,7 +19750,7 @@
           <a:noFill/>
         </p:spPr>
         <p:txBody>
-          <a:bodyPr wrap="square" lIns="0" rIns="0" tIns="0" bIns="0" anchor="t">
+          <a:bodyPr wrap="square" lIns="0" tIns="0" rIns="0" bIns="0" anchor="t">
             <a:spAutoFit/>
           </a:bodyPr>
           <a:lstStyle/>
@@ -19559,7 +19795,7 @@
           <a:noFill/>
         </p:spPr>
         <p:txBody>
-          <a:bodyPr wrap="square" lIns="0" rIns="0" tIns="0" bIns="0" anchor="t">
+          <a:bodyPr wrap="square" lIns="0" tIns="0" rIns="0" bIns="0" anchor="t">
             <a:spAutoFit/>
           </a:bodyPr>
           <a:lstStyle/>
@@ -19604,7 +19840,7 @@
           <a:noFill/>
         </p:spPr>
         <p:txBody>
-          <a:bodyPr wrap="square" lIns="0" rIns="0" tIns="0" bIns="0" anchor="t">
+          <a:bodyPr wrap="square" lIns="0" tIns="0" rIns="0" bIns="0" anchor="t">
             <a:spAutoFit/>
           </a:bodyPr>
           <a:lstStyle/>
@@ -19674,6 +19910,7 @@
           <a:lstStyle/>
           <a:p>
             <a:pPr algn="ctr"/>
+            <a:endParaRPr/>
           </a:p>
         </p:txBody>
       </p:sp>
@@ -19719,6 +19956,7 @@
           <a:lstStyle/>
           <a:p>
             <a:pPr algn="ctr"/>
+            <a:endParaRPr/>
           </a:p>
         </p:txBody>
       </p:sp>
@@ -19739,7 +19977,7 @@
           <a:noFill/>
         </p:spPr>
         <p:txBody>
-          <a:bodyPr wrap="square" lIns="0" rIns="0" tIns="0" bIns="0" anchor="t">
+          <a:bodyPr wrap="square" lIns="0" tIns="0" rIns="0" bIns="0" anchor="t">
             <a:spAutoFit/>
           </a:bodyPr>
           <a:lstStyle/>
@@ -19809,6 +20047,7 @@
           <a:lstStyle/>
           <a:p>
             <a:pPr algn="ctr"/>
+            <a:endParaRPr/>
           </a:p>
         </p:txBody>
       </p:sp>
@@ -19829,7 +20068,7 @@
           <a:noFill/>
         </p:spPr>
         <p:txBody>
-          <a:bodyPr wrap="square" lIns="0" rIns="0" tIns="0" bIns="0" anchor="t">
+          <a:bodyPr wrap="square" lIns="0" tIns="0" rIns="0" bIns="0" anchor="t">
             <a:spAutoFit/>
           </a:bodyPr>
           <a:lstStyle/>
@@ -19874,7 +20113,7 @@
           <a:noFill/>
         </p:spPr>
         <p:txBody>
-          <a:bodyPr wrap="square" lIns="0" rIns="0" tIns="0" bIns="0" anchor="t">
+          <a:bodyPr wrap="square" lIns="0" tIns="0" rIns="0" bIns="0" anchor="t">
             <a:spAutoFit/>
           </a:bodyPr>
           <a:lstStyle/>
@@ -19944,6 +20183,7 @@
           <a:lstStyle/>
           <a:p>
             <a:pPr algn="ctr"/>
+            <a:endParaRPr/>
           </a:p>
         </p:txBody>
       </p:sp>
@@ -19989,6 +20229,7 @@
           <a:lstStyle/>
           <a:p>
             <a:pPr algn="ctr"/>
+            <a:endParaRPr/>
           </a:p>
         </p:txBody>
       </p:sp>
@@ -20009,7 +20250,7 @@
           <a:noFill/>
         </p:spPr>
         <p:txBody>
-          <a:bodyPr wrap="square" lIns="0" rIns="0" tIns="0" bIns="0" anchor="t">
+          <a:bodyPr wrap="square" lIns="0" tIns="0" rIns="0" bIns="0" anchor="t">
             <a:spAutoFit/>
           </a:bodyPr>
           <a:lstStyle/>
@@ -20054,7 +20295,7 @@
           <a:noFill/>
         </p:spPr>
         <p:txBody>
-          <a:bodyPr wrap="square" lIns="0" rIns="0" tIns="0" bIns="0" anchor="t">
+          <a:bodyPr wrap="square" lIns="0" tIns="0" rIns="0" bIns="0" anchor="t">
             <a:spAutoFit/>
           </a:bodyPr>
           <a:lstStyle/>
@@ -20099,7 +20340,7 @@
           <a:noFill/>
         </p:spPr>
         <p:txBody>
-          <a:bodyPr wrap="square" lIns="0" rIns="0" tIns="0" bIns="0" anchor="t">
+          <a:bodyPr wrap="square" lIns="0" tIns="0" rIns="0" bIns="0" anchor="t">
             <a:spAutoFit/>
           </a:bodyPr>
           <a:lstStyle/>
@@ -20169,6 +20410,7 @@
           <a:lstStyle/>
           <a:p>
             <a:pPr algn="ctr"/>
+            <a:endParaRPr/>
           </a:p>
         </p:txBody>
       </p:sp>
@@ -20214,6 +20456,7 @@
           <a:lstStyle/>
           <a:p>
             <a:pPr algn="ctr"/>
+            <a:endParaRPr/>
           </a:p>
         </p:txBody>
       </p:sp>
@@ -20234,7 +20477,7 @@
           <a:noFill/>
         </p:spPr>
         <p:txBody>
-          <a:bodyPr wrap="square" lIns="0" rIns="0" tIns="0" bIns="0" anchor="t">
+          <a:bodyPr wrap="square" lIns="0" tIns="0" rIns="0" bIns="0" anchor="t">
             <a:spAutoFit/>
           </a:bodyPr>
           <a:lstStyle/>
@@ -20304,6 +20547,7 @@
           <a:lstStyle/>
           <a:p>
             <a:pPr algn="ctr"/>
+            <a:endParaRPr/>
           </a:p>
         </p:txBody>
       </p:sp>
@@ -20324,7 +20568,7 @@
           <a:noFill/>
         </p:spPr>
         <p:txBody>
-          <a:bodyPr wrap="square" lIns="0" rIns="0" tIns="0" bIns="0" anchor="t">
+          <a:bodyPr wrap="square" lIns="0" tIns="0" rIns="0" bIns="0" anchor="t">
             <a:spAutoFit/>
           </a:bodyPr>
           <a:lstStyle/>
@@ -20348,6 +20592,70 @@
                 <a:latin typeface="Aptos"/>
               </a:rPr>
               <a:t>Aplicación: priorizar la retención temprana de clientes con poca antigüedad y cargos elevados.</a:t>
+            </a:r>
+          </a:p>
+        </p:txBody>
+      </p:sp>
+      <p:sp>
+        <p:nvSpPr>
+          <p:cNvPr id="49" name="TextBox 47">
+            <a:extLst>
+              <a:ext uri="{FF2B5EF4-FFF2-40B4-BE49-F238E27FC236}">
+                <a16:creationId xmlns:a16="http://schemas.microsoft.com/office/drawing/2014/main" id="{CF6959DF-C841-6F9D-AD80-0273881C9107}"/>
+              </a:ext>
+            </a:extLst>
+          </p:cNvPr>
+          <p:cNvSpPr txBox="1"/>
+          <p:nvPr/>
+        </p:nvSpPr>
+        <p:spPr>
+          <a:xfrm>
+            <a:off x="9774936" y="2313432"/>
+            <a:ext cx="1014984" cy="276999"/>
+          </a:xfrm>
+          <a:prstGeom prst="rect">
+            <a:avLst/>
+          </a:prstGeom>
+          <a:noFill/>
+        </p:spPr>
+        <p:txBody>
+          <a:bodyPr wrap="square" lIns="0" tIns="0" rIns="0" bIns="0" anchor="t">
+            <a:spAutoFit/>
+          </a:bodyPr>
+          <a:lstStyle/>
+          <a:p>
+            <a:pPr algn="l">
+              <a:lnSpc>
+                <a:spcPct val="100000"/>
+              </a:lnSpc>
+              <a:spcBef>
+                <a:spcPts val="0"/>
+              </a:spcBef>
+              <a:spcAft>
+                <a:spcPts val="0"/>
+              </a:spcAft>
+            </a:pPr>
+            <a:r>
+              <a:rPr lang="es-MX" b="1" dirty="0" err="1">
+                <a:solidFill>
+                  <a:schemeClr val="accent3">
+                    <a:lumMod val="75000"/>
+                  </a:schemeClr>
+                </a:solidFill>
+                <a:latin typeface="Aptos"/>
+              </a:rPr>
+              <a:t>Churn</a:t>
+            </a:r>
+            <a:r>
+              <a:rPr b="1" dirty="0">
+                <a:solidFill>
+                  <a:schemeClr val="accent3">
+                    <a:lumMod val="75000"/>
+                  </a:schemeClr>
+                </a:solidFill>
+                <a:latin typeface="Aptos"/>
+              </a:rPr>
+              <a:t>:</a:t>
             </a:r>
           </a:p>
         </p:txBody>
@@ -20361,7 +20669,7 @@
 </file>
 
 <file path=ppt/slides/slide9.xml><?xml version="1.0" encoding="utf-8"?>
-<p:sld xmlns:a="http://schemas.openxmlformats.org/drawingml/2006/main" xmlns:p="http://schemas.openxmlformats.org/presentationml/2006/main" xmlns:r="http://schemas.openxmlformats.org/officeDocument/2006/relationships">
+<p:sld xmlns:a="http://schemas.openxmlformats.org/drawingml/2006/main" xmlns:r="http://schemas.openxmlformats.org/officeDocument/2006/relationships" xmlns:p="http://schemas.openxmlformats.org/presentationml/2006/main">
   <p:cSld>
     <p:bg>
       <p:bgPr>
@@ -20377,7 +20685,14 @@
         <p:cNvGrpSpPr/>
         <p:nvPr/>
       </p:nvGrpSpPr>
-      <p:grpSpPr/>
+      <p:grpSpPr>
+        <a:xfrm>
+          <a:off x="0" y="0"/>
+          <a:ext cx="0" cy="0"/>
+          <a:chOff x="0" y="0"/>
+          <a:chExt cx="0" cy="0"/>
+        </a:xfrm>
+      </p:grpSpPr>
       <p:cxnSp>
         <p:nvCxnSpPr>
           <p:cNvPr id="2" name="Connector 1"/>
@@ -20488,6 +20803,7 @@
           <a:lstStyle/>
           <a:p>
             <a:pPr algn="ctr"/>
+            <a:endParaRPr/>
           </a:p>
         </p:txBody>
       </p:sp>
@@ -20531,6 +20847,7 @@
           <a:lstStyle/>
           <a:p>
             <a:pPr algn="ctr"/>
+            <a:endParaRPr/>
           </a:p>
         </p:txBody>
       </p:sp>
@@ -20574,6 +20891,7 @@
           <a:lstStyle/>
           <a:p>
             <a:pPr algn="ctr"/>
+            <a:endParaRPr/>
           </a:p>
         </p:txBody>
       </p:sp>
@@ -20594,7 +20912,7 @@
           <a:noFill/>
         </p:spPr>
         <p:txBody>
-          <a:bodyPr wrap="square" lIns="0" rIns="0" tIns="0" bIns="0" anchor="t">
+          <a:bodyPr wrap="square" lIns="0" tIns="0" rIns="0" bIns="0" anchor="t">
             <a:spAutoFit/>
           </a:bodyPr>
           <a:lstStyle/>
@@ -20639,7 +20957,7 @@
           <a:noFill/>
         </p:spPr>
         <p:txBody>
-          <a:bodyPr wrap="square" lIns="0" rIns="0" tIns="0" bIns="0" anchor="t">
+          <a:bodyPr wrap="square" lIns="0" tIns="0" rIns="0" bIns="0" anchor="t">
             <a:spAutoFit/>
           </a:bodyPr>
           <a:lstStyle/>
@@ -20719,7 +21037,7 @@
           <a:noFill/>
         </p:spPr>
         <p:txBody>
-          <a:bodyPr wrap="square" lIns="0" rIns="0" tIns="0" bIns="0" anchor="t">
+          <a:bodyPr wrap="square" lIns="0" tIns="0" rIns="0" bIns="0" anchor="t">
             <a:spAutoFit/>
           </a:bodyPr>
           <a:lstStyle/>
@@ -20764,7 +21082,7 @@
           <a:noFill/>
         </p:spPr>
         <p:txBody>
-          <a:bodyPr wrap="square" lIns="0" rIns="0" tIns="0" bIns="0" anchor="t">
+          <a:bodyPr wrap="square" lIns="0" tIns="0" rIns="0" bIns="0" anchor="t">
             <a:spAutoFit/>
           </a:bodyPr>
           <a:lstStyle/>
@@ -20809,7 +21127,7 @@
           <a:noFill/>
         </p:spPr>
         <p:txBody>
-          <a:bodyPr wrap="square" lIns="0" rIns="0" tIns="0" bIns="0" anchor="t">
+          <a:bodyPr wrap="square" lIns="0" tIns="0" rIns="0" bIns="0" anchor="t">
             <a:spAutoFit/>
           </a:bodyPr>
           <a:lstStyle/>
@@ -20877,6 +21195,7 @@
           <a:lstStyle/>
           <a:p>
             <a:pPr algn="ctr"/>
+            <a:endParaRPr/>
           </a:p>
         </p:txBody>
       </p:sp>
@@ -20920,6 +21239,7 @@
           <a:lstStyle/>
           <a:p>
             <a:pPr algn="ctr"/>
+            <a:endParaRPr/>
           </a:p>
         </p:txBody>
       </p:sp>
@@ -20963,6 +21283,7 @@
           <a:lstStyle/>
           <a:p>
             <a:pPr algn="ctr"/>
+            <a:endParaRPr/>
           </a:p>
         </p:txBody>
       </p:sp>
@@ -21006,6 +21327,7 @@
           <a:lstStyle/>
           <a:p>
             <a:pPr algn="ctr"/>
+            <a:endParaRPr/>
           </a:p>
         </p:txBody>
       </p:sp>
@@ -21049,6 +21371,7 @@
           <a:lstStyle/>
           <a:p>
             <a:pPr algn="ctr"/>
+            <a:endParaRPr/>
           </a:p>
         </p:txBody>
       </p:sp>
@@ -21092,6 +21415,7 @@
           <a:lstStyle/>
           <a:p>
             <a:pPr algn="ctr"/>
+            <a:endParaRPr/>
           </a:p>
         </p:txBody>
       </p:sp>
@@ -21135,6 +21459,7 @@
           <a:lstStyle/>
           <a:p>
             <a:pPr algn="ctr"/>
+            <a:endParaRPr/>
           </a:p>
         </p:txBody>
       </p:sp>
@@ -21178,6 +21503,7 @@
           <a:lstStyle/>
           <a:p>
             <a:pPr algn="ctr"/>
+            <a:endParaRPr/>
           </a:p>
         </p:txBody>
       </p:sp>
@@ -21221,6 +21547,7 @@
           <a:lstStyle/>
           <a:p>
             <a:pPr algn="ctr"/>
+            <a:endParaRPr/>
           </a:p>
         </p:txBody>
       </p:sp>
@@ -21264,6 +21591,7 @@
           <a:lstStyle/>
           <a:p>
             <a:pPr algn="ctr"/>
+            <a:endParaRPr/>
           </a:p>
         </p:txBody>
       </p:sp>
@@ -21307,6 +21635,7 @@
           <a:lstStyle/>
           <a:p>
             <a:pPr algn="ctr"/>
+            <a:endParaRPr/>
           </a:p>
         </p:txBody>
       </p:sp>
@@ -21327,7 +21656,7 @@
           <a:noFill/>
         </p:spPr>
         <p:txBody>
-          <a:bodyPr wrap="square" lIns="0" rIns="0" tIns="0" bIns="0" anchor="t">
+          <a:bodyPr wrap="square" lIns="0" tIns="0" rIns="0" bIns="0" anchor="t">
             <a:spAutoFit/>
           </a:bodyPr>
           <a:lstStyle/>
@@ -21372,7 +21701,7 @@
           <a:noFill/>
         </p:spPr>
         <p:txBody>
-          <a:bodyPr wrap="square" lIns="0" rIns="0" tIns="0" bIns="0" anchor="t">
+          <a:bodyPr wrap="square" lIns="0" tIns="0" rIns="0" bIns="0" anchor="t">
             <a:spAutoFit/>
           </a:bodyPr>
           <a:lstStyle/>
@@ -21444,6 +21773,7 @@
           <a:lstStyle/>
           <a:p>
             <a:pPr algn="ctr"/>
+            <a:endParaRPr/>
           </a:p>
         </p:txBody>
       </p:sp>
@@ -21487,6 +21817,7 @@
           <a:lstStyle/>
           <a:p>
             <a:pPr algn="ctr"/>
+            <a:endParaRPr/>
           </a:p>
         </p:txBody>
       </p:sp>
@@ -21507,7 +21838,7 @@
           <a:noFill/>
         </p:spPr>
         <p:txBody>
-          <a:bodyPr wrap="square" lIns="0" rIns="0" tIns="0" bIns="0" anchor="t">
+          <a:bodyPr wrap="square" lIns="0" tIns="0" rIns="0" bIns="0" anchor="t">
             <a:spAutoFit/>
           </a:bodyPr>
           <a:lstStyle/>
@@ -21552,7 +21883,7 @@
           <a:noFill/>
         </p:spPr>
         <p:txBody>
-          <a:bodyPr wrap="square" lIns="0" rIns="0" tIns="0" bIns="0" anchor="t">
+          <a:bodyPr wrap="square" lIns="0" tIns="0" rIns="0" bIns="0" anchor="t">
             <a:spAutoFit/>
           </a:bodyPr>
           <a:lstStyle/>
@@ -21597,7 +21928,7 @@
           <a:noFill/>
         </p:spPr>
         <p:txBody>
-          <a:bodyPr wrap="square" lIns="0" rIns="0" tIns="0" bIns="0" anchor="t">
+          <a:bodyPr wrap="square" lIns="0" tIns="0" rIns="0" bIns="0" anchor="t">
             <a:spAutoFit/>
           </a:bodyPr>
           <a:lstStyle/>
@@ -21669,6 +22000,7 @@
           <a:lstStyle/>
           <a:p>
             <a:pPr algn="ctr"/>
+            <a:endParaRPr/>
           </a:p>
         </p:txBody>
       </p:sp>
@@ -21712,6 +22044,7 @@
           <a:lstStyle/>
           <a:p>
             <a:pPr algn="ctr"/>
+            <a:endParaRPr/>
           </a:p>
         </p:txBody>
       </p:sp>
@@ -21732,7 +22065,7 @@
           <a:noFill/>
         </p:spPr>
         <p:txBody>
-          <a:bodyPr wrap="square" lIns="0" rIns="0" tIns="0" bIns="0" anchor="t">
+          <a:bodyPr wrap="square" lIns="0" tIns="0" rIns="0" bIns="0" anchor="t">
             <a:spAutoFit/>
           </a:bodyPr>
           <a:lstStyle/>
@@ -21777,7 +22110,7 @@
           <a:noFill/>
         </p:spPr>
         <p:txBody>
-          <a:bodyPr wrap="square" lIns="0" rIns="0" tIns="0" bIns="0" anchor="t">
+          <a:bodyPr wrap="square" lIns="0" tIns="0" rIns="0" bIns="0" anchor="t">
             <a:spAutoFit/>
           </a:bodyPr>
           <a:lstStyle/>
@@ -21822,7 +22155,7 @@
           <a:noFill/>
         </p:spPr>
         <p:txBody>
-          <a:bodyPr wrap="square" lIns="0" rIns="0" tIns="0" bIns="0" anchor="t">
+          <a:bodyPr wrap="square" lIns="0" tIns="0" rIns="0" bIns="0" anchor="t">
             <a:spAutoFit/>
           </a:bodyPr>
           <a:lstStyle/>
@@ -21894,6 +22227,7 @@
           <a:lstStyle/>
           <a:p>
             <a:pPr algn="ctr"/>
+            <a:endParaRPr/>
           </a:p>
         </p:txBody>
       </p:sp>
@@ -21937,6 +22271,7 @@
           <a:lstStyle/>
           <a:p>
             <a:pPr algn="ctr"/>
+            <a:endParaRPr/>
           </a:p>
         </p:txBody>
       </p:sp>
@@ -21957,7 +22292,7 @@
           <a:noFill/>
         </p:spPr>
         <p:txBody>
-          <a:bodyPr wrap="square" lIns="0" rIns="0" tIns="0" bIns="0" anchor="t">
+          <a:bodyPr wrap="square" lIns="0" tIns="0" rIns="0" bIns="0" anchor="t">
             <a:spAutoFit/>
           </a:bodyPr>
           <a:lstStyle/>
@@ -22002,7 +22337,7 @@
           <a:noFill/>
         </p:spPr>
         <p:txBody>
-          <a:bodyPr wrap="square" lIns="0" rIns="0" tIns="0" bIns="0" anchor="t">
+          <a:bodyPr wrap="square" lIns="0" tIns="0" rIns="0" bIns="0" anchor="t">
             <a:spAutoFit/>
           </a:bodyPr>
           <a:lstStyle/>
@@ -22047,7 +22382,7 @@
           <a:noFill/>
         </p:spPr>
         <p:txBody>
-          <a:bodyPr wrap="square" lIns="0" rIns="0" tIns="0" bIns="0" anchor="t">
+          <a:bodyPr wrap="square" lIns="0" tIns="0" rIns="0" bIns="0" anchor="t">
             <a:spAutoFit/>
           </a:bodyPr>
           <a:lstStyle/>
@@ -22092,7 +22427,7 @@
           <a:noFill/>
         </p:spPr>
         <p:txBody>
-          <a:bodyPr wrap="square" lIns="0" rIns="0" tIns="0" bIns="0" anchor="t">
+          <a:bodyPr wrap="square" lIns="0" tIns="0" rIns="0" bIns="0" anchor="t">
             <a:spAutoFit/>
           </a:bodyPr>
           <a:lstStyle/>

</xml_diff>